<commit_message>
objectifs: raise the 2026-10-23 deck to a formal register
Titles, captions and the hypothesis cards now use the formal wording
("constitutes a finding", "admitted", "prevailing") in place of the
conversational phrasing, and the hypothesis tests state the property
rather than an illustrative shorthand.

Co-Authored-By: Claude Code <noreply@anthropic.com>
</commit_message>
<xml_diff>
--- a/objectifs/presentation-2026-10-23/slides.pptx
+++ b/objectifs/presentation-2026-10-23/slides.pptx
@@ -5,19 +5,19 @@
     <p:sldMasterId xmlns:r="http://schemas.openxmlformats.org/officeDocument/2006/relationships" id="2147483648" r:id="rId1"/>
   </p:sldMasterIdLst>
   <p:notesMasterIdLst>
-    <p:notesMasterId r:id="R092bac36844248f6"/>
+    <p:notesMasterId r:id="R6cbed7eace1e4934"/>
   </p:notesMasterIdLst>
   <p:sldIdLst>
-    <p:sldId id="256" r:id="R9817429b1ab440e3"/>
-    <p:sldId id="257" r:id="Rb8d843fcd57c44de"/>
-    <p:sldId id="258" r:id="R413ae41856734d67"/>
-    <p:sldId id="259" r:id="Rdf0899c3e0234efb"/>
-    <p:sldId id="260" r:id="R4abcb0d8a9d944c7"/>
-    <p:sldId id="261" r:id="R87cce314b4e44a9d"/>
-    <p:sldId id="262" r:id="R3166467373c44fba"/>
-    <p:sldId id="263" r:id="R62097ac2a76047a8"/>
-    <p:sldId id="264" r:id="R285126a111d941ca"/>
-    <p:sldId id="265" r:id="R9e10d5d7402c4b0a"/>
+    <p:sldId id="256" r:id="R75f6e9be2af74bbb"/>
+    <p:sldId id="257" r:id="Ra0fa2659e3524965"/>
+    <p:sldId id="258" r:id="R8fbb191291b64c71"/>
+    <p:sldId id="259" r:id="Rbc3bbd2717b34707"/>
+    <p:sldId id="260" r:id="R21469df2e8ea43f3"/>
+    <p:sldId id="261" r:id="Rb8cd3ecfc2cc4b59"/>
+    <p:sldId id="262" r:id="R1f1e14a25e014efe"/>
+    <p:sldId id="263" r:id="R16a374eaf6d9405d"/>
+    <p:sldId id="264" r:id="R4ffe4907288d4f02"/>
+    <p:sldId id="265" r:id="Rafc6967a6b914dd4"/>
   </p:sldIdLst>
   <p:sldSz cx="12192000" cy="6858000" type="custom"/>
   <p:notesSz cx="6858000" cy="9144000"/>
@@ -1466,7 +1466,7 @@
                 <a:latin typeface="Arial"/>
                 <a:ea typeface="Arial"/>
               </a:rPr>
-              <a:t>An autonomous, provable auditor</a:t>
+              <a:t>An autonomous and verifiable auditor</a:t>
             </a:r>
           </a:p>
           <a:p xmlns:a="http://schemas.openxmlformats.org/drawingml/2006/main">
@@ -1596,7 +1596,7 @@
                 <a:latin typeface="Arial"/>
                 <a:ea typeface="Arial"/>
               </a:rPr>
-              <a:t>Work in progress.</a:t>
+              <a:t>Status: work in progress.</a:t>
             </a:r>
           </a:p>
         </p:txBody>
@@ -1610,7 +1610,7 @@
           <p:nvPr/>
         </p:nvPicPr>
         <p:blipFill>
-          <a:blip xmlns:r="http://schemas.openxmlformats.org/officeDocument/2006/relationships" xmlns:a="http://schemas.openxmlformats.org/drawingml/2006/main" r:embed="Re6cd744afa8e4c92"/>
+          <a:blip xmlns:r="http://schemas.openxmlformats.org/officeDocument/2006/relationships" xmlns:a="http://schemas.openxmlformats.org/drawingml/2006/main" r:embed="Rfe84a2907b8547a1"/>
           <a:stretch xmlns:a="http://schemas.openxmlformats.org/drawingml/2006/main">
             <a:fillRect/>
           </a:stretch>
@@ -1656,7 +1656,7 @@
           <p:nvPr/>
         </p:nvPicPr>
         <p:blipFill>
-          <a:blip xmlns:r="http://schemas.openxmlformats.org/officeDocument/2006/relationships" xmlns:a="http://schemas.openxmlformats.org/drawingml/2006/main" r:embed="Ra9501adc556441cf"/>
+          <a:blip xmlns:r="http://schemas.openxmlformats.org/officeDocument/2006/relationships" xmlns:a="http://schemas.openxmlformats.org/drawingml/2006/main" r:embed="R3f042151ad9547a9"/>
           <a:stretch xmlns:a="http://schemas.openxmlformats.org/drawingml/2006/main">
             <a:fillRect/>
           </a:stretch>
@@ -2597,7 +2597,7 @@
           <p:nvPr/>
         </p:nvPicPr>
         <p:blipFill>
-          <a:blip xmlns:r="http://schemas.openxmlformats.org/officeDocument/2006/relationships" xmlns:a="http://schemas.openxmlformats.org/drawingml/2006/main" r:embed="R68e6b26510e94b73"/>
+          <a:blip xmlns:r="http://schemas.openxmlformats.org/officeDocument/2006/relationships" xmlns:a="http://schemas.openxmlformats.org/drawingml/2006/main" r:embed="R382009805d2b4c8a"/>
           <a:stretch xmlns:a="http://schemas.openxmlformats.org/drawingml/2006/main">
             <a:fillRect/>
           </a:stretch>
@@ -2995,7 +2995,7 @@
                 <a:latin typeface="Arial"/>
                 <a:ea typeface="Arial"/>
               </a:rPr>
-              <a:t>An auditor that explores, finds,</a:t>
+              <a:t>An auditor that explores, identifies,</a:t>
             </a:r>
           </a:p>
           <a:p xmlns:a="http://schemas.openxmlformats.org/drawingml/2006/main">
@@ -3120,14 +3120,14 @@
           <a:p xmlns:a="http://schemas.openxmlformats.org/drawingml/2006/main">
             <a:pPr algn="ctr"/>
             <a:r>
-              <a:rPr lang="en-US" sz="1900" b="1" i="0">
+              <a:rPr lang="en-US" sz="1850" b="1" i="0">
                 <a:solidFill>
                   <a:srgbClr val="20252D"/>
                 </a:solidFill>
                 <a:latin typeface="Arial"/>
                 <a:ea typeface="Arial"/>
               </a:rPr>
-              <a:t>Which conditions</a:t>
+              <a:t>Under which conditions</a:t>
             </a:r>
           </a:p>
         </p:txBody>
@@ -3166,7 +3166,7 @@
                 <a:latin typeface="Arial"/>
                 <a:ea typeface="Arial"/>
               </a:rPr>
-              <a:t>not which model wins</a:t>
+              <a:t>rather than which model prevails</a:t>
             </a:r>
           </a:p>
         </p:txBody>
@@ -3240,14 +3240,14 @@
           <a:p xmlns:a="http://schemas.openxmlformats.org/drawingml/2006/main">
             <a:pPr algn="ctr"/>
             <a:r>
-              <a:rPr lang="en-US" sz="1750" b="1" i="0">
+              <a:rPr lang="en-US" sz="1700" b="1" i="0">
                 <a:solidFill>
                   <a:srgbClr val="20252D"/>
                 </a:solidFill>
                 <a:latin typeface="Arial"/>
                 <a:ea typeface="Arial"/>
               </a:rPr>
-              <a:t>Same tools, same budget</a:t>
+              <a:t>Identical tools and budget</a:t>
             </a:r>
           </a:p>
         </p:txBody>
@@ -3367,7 +3367,7 @@
                 <a:latin typeface="Arial"/>
                 <a:ea typeface="Arial"/>
               </a:rPr>
-              <a:t>Proof, not opinion</a:t>
+              <a:t>Evidence, not assertion</a:t>
             </a:r>
           </a:p>
         </p:txBody>
@@ -3483,7 +3483,7 @@
                 <a:latin typeface="Arial"/>
                 <a:ea typeface="Arial"/>
               </a:rPr>
-              <a:t>Model training is out of priority.</a:t>
+              <a:t>Model training is not a current priority.</a:t>
             </a:r>
           </a:p>
         </p:txBody>
@@ -3519,7 +3519,7 @@
           <p:nvPr/>
         </p:nvPicPr>
         <p:blipFill>
-          <a:blip xmlns:r="http://schemas.openxmlformats.org/officeDocument/2006/relationships" xmlns:a="http://schemas.openxmlformats.org/drawingml/2006/main" r:embed="R3032364bc9ea42d3"/>
+          <a:blip xmlns:r="http://schemas.openxmlformats.org/officeDocument/2006/relationships" xmlns:a="http://schemas.openxmlformats.org/drawingml/2006/main" r:embed="R23e560a804a04617"/>
           <a:stretch xmlns:a="http://schemas.openxmlformats.org/drawingml/2006/main">
             <a:fillRect/>
           </a:stretch>
@@ -3953,14 +3953,14 @@
           <a:p xmlns:a="http://schemas.openxmlformats.org/drawingml/2006/main">
             <a:pPr algn="ctr"/>
             <a:r>
-              <a:rPr lang="en-US" sz="1500" b="0" i="0">
+              <a:rPr lang="en-US" sz="1300" b="0" i="0">
                 <a:solidFill>
                   <a:srgbClr val="5C626C"/>
                 </a:solidFill>
                 <a:latin typeface="Arial"/>
                 <a:ea typeface="Arial"/>
               </a:rPr>
-              <a:t>networks we know</a:t>
+              <a:t>networks with known ground truth</a:t>
             </a:r>
           </a:p>
         </p:txBody>
@@ -4042,7 +4042,7 @@
                 <a:latin typeface="Arial"/>
                 <a:ea typeface="Arial"/>
               </a:rPr>
-              <a:t>runs the audit</a:t>
+              <a:t>conducts the audit</a:t>
             </a:r>
           </a:p>
         </p:txBody>
@@ -4124,7 +4124,7 @@
                 <a:latin typeface="Arial"/>
                 <a:ea typeface="Arial"/>
               </a:rPr>
-              <a:t>judges the result</a:t>
+              <a:t>assesses the result</a:t>
             </a:r>
           </a:p>
         </p:txBody>
@@ -4213,7 +4213,7 @@
                 <a:latin typeface="Arial"/>
                 <a:ea typeface="Arial"/>
               </a:rPr>
-              <a:t>The model is one piece among them.</a:t>
+              <a:t>The model is one component among them.</a:t>
             </a:r>
           </a:p>
         </p:txBody>
@@ -4252,7 +4252,7 @@
                 <a:latin typeface="Arial"/>
                 <a:ea typeface="Arial"/>
               </a:rPr>
-              <a:t>A run becomes a measurement only against a known ground truth.</a:t>
+              <a:t>A run constitutes a measurement only against known ground truth.</a:t>
             </a:r>
           </a:p>
         </p:txBody>
@@ -4288,7 +4288,7 @@
           <p:nvPr/>
         </p:nvPicPr>
         <p:blipFill>
-          <a:blip xmlns:r="http://schemas.openxmlformats.org/officeDocument/2006/relationships" xmlns:a="http://schemas.openxmlformats.org/drawingml/2006/main" r:embed="Ra8d2f1174614486f"/>
+          <a:blip xmlns:r="http://schemas.openxmlformats.org/officeDocument/2006/relationships" xmlns:a="http://schemas.openxmlformats.org/drawingml/2006/main" r:embed="Rd5a3c1d73625464f"/>
           <a:stretch xmlns:a="http://schemas.openxmlformats.org/drawingml/2006/main">
             <a:fillRect/>
           </a:stretch>
@@ -4337,7 +4337,7 @@
                 <a:latin typeface="Arial"/>
                 <a:ea typeface="Arial"/>
               </a:rPr>
-              <a:t>What counts as “found”</a:t>
+              <a:t>What constitutes a finding</a:t>
             </a:r>
           </a:p>
         </p:txBody>
@@ -4726,7 +4726,7 @@
                 <a:latin typeface="Arial"/>
                 <a:ea typeface="Arial"/>
               </a:rPr>
-              <a:t>“I read another organisation's data.”</a:t>
+              <a:t>“I have read another organisation's data.”</a:t>
             </a:r>
           </a:p>
         </p:txBody>
@@ -4765,7 +4765,7 @@
                 <a:latin typeface="Arial"/>
                 <a:ea typeface="Arial"/>
               </a:rPr>
-              <a:t>✕   Not counted</a:t>
+              <a:t>✕   Not admitted</a:t>
             </a:r>
           </a:p>
         </p:txBody>
@@ -4857,7 +4857,7 @@
                 <a:latin typeface="Arial"/>
                 <a:ea typeface="Arial"/>
               </a:rPr>
-              <a:t>hold the data.</a:t>
+              <a:t>contain the data.</a:t>
             </a:r>
           </a:p>
         </p:txBody>
@@ -4896,7 +4896,7 @@
                 <a:latin typeface="Arial"/>
                 <a:ea typeface="Arial"/>
               </a:rPr>
-              <a:t>✓   Counted</a:t>
+              <a:t>✓   Admitted</a:t>
             </a:r>
           </a:p>
         </p:txBody>
@@ -4935,7 +4935,7 @@
                 <a:latin typeface="Arial"/>
                 <a:ea typeface="Arial"/>
               </a:rPr>
-              <a:t>We recompute it from the log.</a:t>
+              <a:t>The finding is recomputed from the log;</a:t>
             </a:r>
           </a:p>
           <a:p xmlns:a="http://schemas.openxmlformats.org/drawingml/2006/main">
@@ -4948,7 +4948,7 @@
                 <a:latin typeface="Arial"/>
                 <a:ea typeface="Arial"/>
               </a:rPr>
-              <a:t>We never trust the conclusion.</a:t>
+              <a:t>the conclusion is never taken on trust.</a:t>
             </a:r>
           </a:p>
         </p:txBody>
@@ -4987,7 +4987,7 @@
                 <a:latin typeface="Arial"/>
                 <a:ea typeface="Arial"/>
               </a:rPr>
-              <a:t>The same trial runs on a healthy and on a vulnerable network.</a:t>
+              <a:t>The same trial is conducted on a healthy and on a vulnerable network.</a:t>
             </a:r>
           </a:p>
           <a:p xmlns:a="http://schemas.openxmlformats.org/drawingml/2006/main">
@@ -5000,7 +5000,7 @@
                 <a:latin typeface="Arial"/>
                 <a:ea typeface="Arial"/>
               </a:rPr>
-              <a:t>Finding something in the healthy one is an error.</a:t>
+              <a:t>A finding reported on the healthy one is recorded as an error.</a:t>
             </a:r>
           </a:p>
         </p:txBody>
@@ -5036,7 +5036,7 @@
           <p:nvPr/>
         </p:nvPicPr>
         <p:blipFill>
-          <a:blip xmlns:r="http://schemas.openxmlformats.org/officeDocument/2006/relationships" xmlns:a="http://schemas.openxmlformats.org/drawingml/2006/main" r:embed="R4741c4178dcf4162"/>
+          <a:blip xmlns:r="http://schemas.openxmlformats.org/officeDocument/2006/relationships" xmlns:a="http://schemas.openxmlformats.org/drawingml/2006/main" r:embed="R5aa39dada269443d"/>
           <a:stretch xmlns:a="http://schemas.openxmlformats.org/drawingml/2006/main">
             <a:fillRect/>
           </a:stretch>
@@ -5085,7 +5085,7 @@
                 <a:latin typeface="Arial"/>
                 <a:ea typeface="Arial"/>
               </a:rPr>
-              <a:t>Where we are</a:t>
+              <a:t>Current status</a:t>
             </a:r>
           </a:p>
         </p:txBody>
@@ -5434,7 +5434,7 @@
                 <a:latin typeface="Arial"/>
                 <a:ea typeface="Arial"/>
               </a:rPr>
-              <a:t>Both approaches succeed everywhere.</a:t>
+              <a:t>Both approaches succeed on every configuration.</a:t>
             </a:r>
           </a:p>
         </p:txBody>
@@ -5448,7 +5448,7 @@
         <p:spPr>
           <a:xfrm xmlns:a="http://schemas.openxmlformats.org/drawingml/2006/main">
             <a:off x="1872000" y="2880000"/>
-            <a:ext cx="1368000" cy="432000"/>
+            <a:ext cx="1656000" cy="432000"/>
           </a:xfrm>
           <a:prstGeom xmlns:a="http://schemas.openxmlformats.org/drawingml/2006/main" prst="rect">
             <a:avLst/>
@@ -5473,7 +5473,7 @@
                 <a:latin typeface="Arial"/>
                 <a:ea typeface="Arial"/>
               </a:rPr>
-              <a:t>Rules</a:t>
+              <a:t>Rule-based</a:t>
             </a:r>
           </a:p>
         </p:txBody>
@@ -5486,8 +5486,8 @@
         </p:nvSpPr>
         <p:spPr>
           <a:xfrm xmlns:a="http://schemas.openxmlformats.org/drawingml/2006/main">
-            <a:off x="3456000" y="2934000"/>
-            <a:ext cx="4536000" cy="324000"/>
+            <a:off x="3744000" y="2934000"/>
+            <a:ext cx="4248000" cy="324000"/>
           </a:xfrm>
           <a:prstGeom xmlns:a="http://schemas.openxmlformats.org/drawingml/2006/main" prst="rect">
             <a:avLst/>
@@ -5564,32 +5564,32 @@
         <p:spPr>
           <a:xfrm xmlns:a="http://schemas.openxmlformats.org/drawingml/2006/main">
             <a:off x="1872000" y="3708000"/>
-            <a:ext cx="1368000" cy="432000"/>
-          </a:xfrm>
-          <a:prstGeom xmlns:a="http://schemas.openxmlformats.org/drawingml/2006/main" prst="rect">
-            <a:avLst/>
-          </a:prstGeom>
-          <a:noFill xmlns:a="http://schemas.openxmlformats.org/drawingml/2006/main"/>
-          <a:ln xmlns:a="http://schemas.openxmlformats.org/drawingml/2006/main">
-            <a:noFill/>
-          </a:ln>
-        </p:spPr>
-        <p:txBody>
-          <a:bodyPr xmlns:a="http://schemas.openxmlformats.org/drawingml/2006/main" lIns="0" tIns="0" rIns="0" bIns="0" anchor="ctr">
-            <a:noAutofit/>
-          </a:bodyPr>
-          <a:lstStyle xmlns:a="http://schemas.openxmlformats.org/drawingml/2006/main"/>
-          <a:p xmlns:a="http://schemas.openxmlformats.org/drawingml/2006/main">
-            <a:pPr algn="l"/>
-            <a:r>
-              <a:rPr lang="en-US" sz="1800" b="1" i="0">
+            <a:ext cx="1656000" cy="432000"/>
+          </a:xfrm>
+          <a:prstGeom xmlns:a="http://schemas.openxmlformats.org/drawingml/2006/main" prst="rect">
+            <a:avLst/>
+          </a:prstGeom>
+          <a:noFill xmlns:a="http://schemas.openxmlformats.org/drawingml/2006/main"/>
+          <a:ln xmlns:a="http://schemas.openxmlformats.org/drawingml/2006/main">
+            <a:noFill/>
+          </a:ln>
+        </p:spPr>
+        <p:txBody>
+          <a:bodyPr xmlns:a="http://schemas.openxmlformats.org/drawingml/2006/main" lIns="0" tIns="0" rIns="0" bIns="0" anchor="ctr">
+            <a:noAutofit/>
+          </a:bodyPr>
+          <a:lstStyle xmlns:a="http://schemas.openxmlformats.org/drawingml/2006/main"/>
+          <a:p xmlns:a="http://schemas.openxmlformats.org/drawingml/2006/main">
+            <a:pPr algn="l"/>
+            <a:r>
+              <a:rPr lang="en-US" sz="1700" b="1" i="0">
                 <a:solidFill>
                   <a:srgbClr val="20252D"/>
                 </a:solidFill>
                 <a:latin typeface="Arial"/>
                 <a:ea typeface="Arial"/>
               </a:rPr>
-              <a:t>Model</a:t>
+              <a:t>Model-based</a:t>
             </a:r>
           </a:p>
         </p:txBody>
@@ -5602,8 +5602,8 @@
         </p:nvSpPr>
         <p:spPr>
           <a:xfrm xmlns:a="http://schemas.openxmlformats.org/drawingml/2006/main">
-            <a:off x="3456000" y="3762000"/>
-            <a:ext cx="4536000" cy="324000"/>
+            <a:off x="3744000" y="3762000"/>
+            <a:ext cx="4248000" cy="324000"/>
           </a:xfrm>
           <a:prstGeom xmlns:a="http://schemas.openxmlformats.org/drawingml/2006/main" prst="rect">
             <a:avLst/>
@@ -5705,7 +5705,7 @@
                 <a:latin typeface="Arial"/>
                 <a:ea typeface="Arial"/>
               </a:rPr>
-              <a:t>It cannot tell them apart.</a:t>
+              <a:t>The instrument does not discriminate between them.</a:t>
             </a:r>
           </a:p>
         </p:txBody>
@@ -5744,7 +5744,7 @@
                 <a:latin typeface="Arial"/>
                 <a:ea typeface="Arial"/>
               </a:rPr>
-              <a:t>Not a failure of the model — a failure of the instrument.</a:t>
+              <a:t>This is a limitation of the instrument, not of the model.</a:t>
             </a:r>
           </a:p>
         </p:txBody>
@@ -5780,7 +5780,7 @@
           <p:nvPr/>
         </p:nvPicPr>
         <p:blipFill>
-          <a:blip xmlns:r="http://schemas.openxmlformats.org/officeDocument/2006/relationships" xmlns:a="http://schemas.openxmlformats.org/drawingml/2006/main" r:embed="R8edfeeac8f824db0"/>
+          <a:blip xmlns:r="http://schemas.openxmlformats.org/officeDocument/2006/relationships" xmlns:a="http://schemas.openxmlformats.org/drawingml/2006/main" r:embed="R6cf621d1d4c645df"/>
           <a:stretch xmlns:a="http://schemas.openxmlformats.org/drawingml/2006/main">
             <a:fillRect/>
           </a:stretch>
@@ -5829,7 +5829,7 @@
                 <a:latin typeface="Arial"/>
                 <a:ea typeface="Arial"/>
               </a:rPr>
-              <a:t>The objective, restated as hypotheses</a:t>
+              <a:t>The objective restated as hypotheses</a:t>
             </a:r>
           </a:p>
         </p:txBody>
@@ -6271,32 +6271,32 @@
         <p:spPr>
           <a:xfrm xmlns:a="http://schemas.openxmlformats.org/drawingml/2006/main">
             <a:off x="1008000" y="2592000"/>
-            <a:ext cx="2916000" cy="432000"/>
-          </a:xfrm>
-          <a:prstGeom xmlns:a="http://schemas.openxmlformats.org/drawingml/2006/main" prst="rect">
-            <a:avLst/>
-          </a:prstGeom>
-          <a:noFill xmlns:a="http://schemas.openxmlformats.org/drawingml/2006/main"/>
-          <a:ln xmlns:a="http://schemas.openxmlformats.org/drawingml/2006/main">
-            <a:noFill/>
-          </a:ln>
-        </p:spPr>
-        <p:txBody>
-          <a:bodyPr xmlns:a="http://schemas.openxmlformats.org/drawingml/2006/main" lIns="0" tIns="0" rIns="0" bIns="0" anchor="ctr">
-            <a:noAutofit/>
-          </a:bodyPr>
-          <a:lstStyle xmlns:a="http://schemas.openxmlformats.org/drawingml/2006/main"/>
-          <a:p xmlns:a="http://schemas.openxmlformats.org/drawingml/2006/main">
-            <a:pPr algn="l"/>
-            <a:r>
-              <a:rPr lang="en-US" sz="1500" b="0" i="0">
+            <a:ext cx="2916000" cy="468000"/>
+          </a:xfrm>
+          <a:prstGeom xmlns:a="http://schemas.openxmlformats.org/drawingml/2006/main" prst="rect">
+            <a:avLst/>
+          </a:prstGeom>
+          <a:noFill xmlns:a="http://schemas.openxmlformats.org/drawingml/2006/main"/>
+          <a:ln xmlns:a="http://schemas.openxmlformats.org/drawingml/2006/main">
+            <a:noFill/>
+          </a:ln>
+        </p:spPr>
+        <p:txBody>
+          <a:bodyPr xmlns:a="http://schemas.openxmlformats.org/drawingml/2006/main" lIns="0" tIns="0" rIns="0" bIns="0" anchor="ctr">
+            <a:noAutofit/>
+          </a:bodyPr>
+          <a:lstStyle xmlns:a="http://schemas.openxmlformats.org/drawingml/2006/main"/>
+          <a:p xmlns:a="http://schemas.openxmlformats.org/drawingml/2006/main">
+            <a:pPr algn="l"/>
+            <a:r>
+              <a:rPr lang="en-US" sz="1350" b="0" i="0">
                 <a:solidFill>
                   <a:srgbClr val="5C626C"/>
                 </a:solidFill>
                 <a:latin typeface="Arial"/>
                 <a:ea typeface="Arial"/>
               </a:rPr>
-              <a:t>a hidden link</a:t>
+              <a:t>a link absent from public inputs</a:t>
             </a:r>
           </a:p>
         </p:txBody>
@@ -6407,14 +6407,14 @@
           <a:p xmlns:a="http://schemas.openxmlformats.org/drawingml/2006/main">
             <a:pPr algn="l"/>
             <a:r>
-              <a:rPr lang="en-US" sz="1500" b="1" i="0">
+              <a:rPr lang="en-US" sz="1250" b="1" i="0">
                 <a:solidFill>
                   <a:srgbClr val="20252D"/>
                 </a:solidFill>
                 <a:latin typeface="Arial"/>
                 <a:ea typeface="Arial"/>
               </a:rPr>
-              <a:t>Mixed formats</a:t>
+              <a:t>Heterogeneous formats</a:t>
             </a:r>
           </a:p>
         </p:txBody>
@@ -6428,32 +6428,32 @@
         <p:spPr>
           <a:xfrm xmlns:a="http://schemas.openxmlformats.org/drawingml/2006/main">
             <a:off x="4572000" y="2592000"/>
-            <a:ext cx="2916000" cy="432000"/>
-          </a:xfrm>
-          <a:prstGeom xmlns:a="http://schemas.openxmlformats.org/drawingml/2006/main" prst="rect">
-            <a:avLst/>
-          </a:prstGeom>
-          <a:noFill xmlns:a="http://schemas.openxmlformats.org/drawingml/2006/main"/>
-          <a:ln xmlns:a="http://schemas.openxmlformats.org/drawingml/2006/main">
-            <a:noFill/>
-          </a:ln>
-        </p:spPr>
-        <p:txBody>
-          <a:bodyPr xmlns:a="http://schemas.openxmlformats.org/drawingml/2006/main" lIns="0" tIns="0" rIns="0" bIns="0" anchor="ctr">
-            <a:noAutofit/>
-          </a:bodyPr>
-          <a:lstStyle xmlns:a="http://schemas.openxmlformats.org/drawingml/2006/main"/>
-          <a:p xmlns:a="http://schemas.openxmlformats.org/drawingml/2006/main">
-            <a:pPr algn="l"/>
-            <a:r>
-              <a:rPr lang="en-US" sz="1500" b="0" i="0">
+            <a:ext cx="2916000" cy="468000"/>
+          </a:xfrm>
+          <a:prstGeom xmlns:a="http://schemas.openxmlformats.org/drawingml/2006/main" prst="rect">
+            <a:avLst/>
+          </a:prstGeom>
+          <a:noFill xmlns:a="http://schemas.openxmlformats.org/drawingml/2006/main"/>
+          <a:ln xmlns:a="http://schemas.openxmlformats.org/drawingml/2006/main">
+            <a:noFill/>
+          </a:ln>
+        </p:spPr>
+        <p:txBody>
+          <a:bodyPr xmlns:a="http://schemas.openxmlformats.org/drawingml/2006/main" lIns="0" tIns="0" rIns="0" bIns="0" anchor="ctr">
+            <a:noAutofit/>
+          </a:bodyPr>
+          <a:lstStyle xmlns:a="http://schemas.openxmlformats.org/drawingml/2006/main"/>
+          <a:p xmlns:a="http://schemas.openxmlformats.org/drawingml/2006/main">
+            <a:pPr algn="l"/>
+            <a:r>
+              <a:rPr lang="en-US" sz="1250" b="0" i="0">
                 <a:solidFill>
                   <a:srgbClr val="5C626C"/>
                 </a:solidFill>
                 <a:latin typeface="Arial"/>
                 <a:ea typeface="Arial"/>
               </a:rPr>
-              <a:t>an unknown parser</a:t>
+              <a:t>a representation no parser covers</a:t>
             </a:r>
           </a:p>
         </p:txBody>
@@ -6571,7 +6571,7 @@
                 <a:latin typeface="Arial"/>
                 <a:ea typeface="Arial"/>
               </a:rPr>
-              <a:t>Unseen contracts</a:t>
+              <a:t>Novel contracts</a:t>
             </a:r>
           </a:p>
         </p:txBody>
@@ -6585,32 +6585,32 @@
         <p:spPr>
           <a:xfrm xmlns:a="http://schemas.openxmlformats.org/drawingml/2006/main">
             <a:off x="8136000" y="2592000"/>
-            <a:ext cx="2916000" cy="432000"/>
-          </a:xfrm>
-          <a:prstGeom xmlns:a="http://schemas.openxmlformats.org/drawingml/2006/main" prst="rect">
-            <a:avLst/>
-          </a:prstGeom>
-          <a:noFill xmlns:a="http://schemas.openxmlformats.org/drawingml/2006/main"/>
-          <a:ln xmlns:a="http://schemas.openxmlformats.org/drawingml/2006/main">
-            <a:noFill/>
-          </a:ln>
-        </p:spPr>
-        <p:txBody>
-          <a:bodyPr xmlns:a="http://schemas.openxmlformats.org/drawingml/2006/main" lIns="0" tIns="0" rIns="0" bIns="0" anchor="ctr">
-            <a:noAutofit/>
-          </a:bodyPr>
-          <a:lstStyle xmlns:a="http://schemas.openxmlformats.org/drawingml/2006/main"/>
-          <a:p xmlns:a="http://schemas.openxmlformats.org/drawingml/2006/main">
-            <a:pPr algn="l"/>
-            <a:r>
-              <a:rPr lang="en-US" sz="1500" b="0" i="0">
+            <a:ext cx="2916000" cy="468000"/>
+          </a:xfrm>
+          <a:prstGeom xmlns:a="http://schemas.openxmlformats.org/drawingml/2006/main" prst="rect">
+            <a:avLst/>
+          </a:prstGeom>
+          <a:noFill xmlns:a="http://schemas.openxmlformats.org/drawingml/2006/main"/>
+          <a:ln xmlns:a="http://schemas.openxmlformats.org/drawingml/2006/main">
+            <a:noFill/>
+          </a:ln>
+        </p:spPr>
+        <p:txBody>
+          <a:bodyPr xmlns:a="http://schemas.openxmlformats.org/drawingml/2006/main" lIns="0" tIns="0" rIns="0" bIns="0" anchor="ctr">
+            <a:noAutofit/>
+          </a:bodyPr>
+          <a:lstStyle xmlns:a="http://schemas.openxmlformats.org/drawingml/2006/main"/>
+          <a:p xmlns:a="http://schemas.openxmlformats.org/drawingml/2006/main">
+            <a:pPr algn="l"/>
+            <a:r>
+              <a:rPr lang="en-US" sz="1100" b="0" i="0">
                 <a:solidFill>
                   <a:srgbClr val="5C626C"/>
                 </a:solidFill>
                 <a:latin typeface="Arial"/>
                 <a:ea typeface="Arial"/>
               </a:rPr>
-              <a:t>undocumented rights</a:t>
+              <a:t>rights stated in unseen documentation</a:t>
             </a:r>
           </a:p>
         </p:txBody>
@@ -6728,7 +6728,7 @@
                 <a:latin typeface="Arial"/>
                 <a:ea typeface="Arial"/>
               </a:rPr>
-              <a:t>Vendor meaning</a:t>
+              <a:t>Vendor semantics</a:t>
             </a:r>
           </a:p>
         </p:txBody>
@@ -6742,32 +6742,32 @@
         <p:spPr>
           <a:xfrm xmlns:a="http://schemas.openxmlformats.org/drawingml/2006/main">
             <a:off x="1008000" y="4068000"/>
-            <a:ext cx="2916000" cy="432000"/>
-          </a:xfrm>
-          <a:prstGeom xmlns:a="http://schemas.openxmlformats.org/drawingml/2006/main" prst="rect">
-            <a:avLst/>
-          </a:prstGeom>
-          <a:noFill xmlns:a="http://schemas.openxmlformats.org/drawingml/2006/main"/>
-          <a:ln xmlns:a="http://schemas.openxmlformats.org/drawingml/2006/main">
-            <a:noFill/>
-          </a:ln>
-        </p:spPr>
-        <p:txBody>
-          <a:bodyPr xmlns:a="http://schemas.openxmlformats.org/drawingml/2006/main" lIns="0" tIns="0" rIns="0" bIns="0" anchor="ctr">
-            <a:noAutofit/>
-          </a:bodyPr>
-          <a:lstStyle xmlns:a="http://schemas.openxmlformats.org/drawingml/2006/main"/>
-          <a:p xmlns:a="http://schemas.openxmlformats.org/drawingml/2006/main">
-            <a:pPr algn="l"/>
-            <a:r>
-              <a:rPr lang="en-US" sz="1500" b="0" i="0">
+            <a:ext cx="2916000" cy="468000"/>
+          </a:xfrm>
+          <a:prstGeom xmlns:a="http://schemas.openxmlformats.org/drawingml/2006/main" prst="rect">
+            <a:avLst/>
+          </a:prstGeom>
+          <a:noFill xmlns:a="http://schemas.openxmlformats.org/drawingml/2006/main"/>
+          <a:ln xmlns:a="http://schemas.openxmlformats.org/drawingml/2006/main">
+            <a:noFill/>
+          </a:ln>
+        </p:spPr>
+        <p:txBody>
+          <a:bodyPr xmlns:a="http://schemas.openxmlformats.org/drawingml/2006/main" lIns="0" tIns="0" rIns="0" bIns="0" anchor="ctr">
+            <a:noAutofit/>
+          </a:bodyPr>
+          <a:lstStyle xmlns:a="http://schemas.openxmlformats.org/drawingml/2006/main"/>
+          <a:p xmlns:a="http://schemas.openxmlformats.org/drawingml/2006/main">
+            <a:pPr algn="l"/>
+            <a:r>
+              <a:rPr lang="en-US" sz="1100" b="0" i="0">
                 <a:solidFill>
                   <a:srgbClr val="5C626C"/>
                 </a:solidFill>
                 <a:latin typeface="Arial"/>
                 <a:ea typeface="Arial"/>
               </a:rPr>
-              <a:t>a field's sense</a:t>
+              <a:t>a field whose meaning is only documented</a:t>
             </a:r>
           </a:p>
         </p:txBody>
@@ -6878,14 +6878,14 @@
           <a:p xmlns:a="http://schemas.openxmlformats.org/drawingml/2006/main">
             <a:pPr algn="l"/>
             <a:r>
-              <a:rPr lang="en-US" sz="1500" b="1" i="0">
+              <a:rPr lang="en-US" sz="1450" b="1" i="0">
                 <a:solidFill>
                   <a:srgbClr val="20252D"/>
                 </a:solidFill>
                 <a:latin typeface="Arial"/>
                 <a:ea typeface="Arial"/>
               </a:rPr>
-              <a:t>Refusals</a:t>
+              <a:t>Ambiguous refusals</a:t>
             </a:r>
           </a:p>
         </p:txBody>
@@ -6899,32 +6899,32 @@
         <p:spPr>
           <a:xfrm xmlns:a="http://schemas.openxmlformats.org/drawingml/2006/main">
             <a:off x="4572000" y="4068000"/>
-            <a:ext cx="2916000" cy="432000"/>
-          </a:xfrm>
-          <a:prstGeom xmlns:a="http://schemas.openxmlformats.org/drawingml/2006/main" prst="rect">
-            <a:avLst/>
-          </a:prstGeom>
-          <a:noFill xmlns:a="http://schemas.openxmlformats.org/drawingml/2006/main"/>
-          <a:ln xmlns:a="http://schemas.openxmlformats.org/drawingml/2006/main">
-            <a:noFill/>
-          </a:ln>
-        </p:spPr>
-        <p:txBody>
-          <a:bodyPr xmlns:a="http://schemas.openxmlformats.org/drawingml/2006/main" lIns="0" tIns="0" rIns="0" bIns="0" anchor="ctr">
-            <a:noAutofit/>
-          </a:bodyPr>
-          <a:lstStyle xmlns:a="http://schemas.openxmlformats.org/drawingml/2006/main"/>
-          <a:p xmlns:a="http://schemas.openxmlformats.org/drawingml/2006/main">
-            <a:pPr algn="l"/>
-            <a:r>
-              <a:rPr lang="en-US" sz="1500" b="0" i="0">
+            <a:ext cx="2916000" cy="468000"/>
+          </a:xfrm>
+          <a:prstGeom xmlns:a="http://schemas.openxmlformats.org/drawingml/2006/main" prst="rect">
+            <a:avLst/>
+          </a:prstGeom>
+          <a:noFill xmlns:a="http://schemas.openxmlformats.org/drawingml/2006/main"/>
+          <a:ln xmlns:a="http://schemas.openxmlformats.org/drawingml/2006/main">
+            <a:noFill/>
+          </a:ln>
+        </p:spPr>
+        <p:txBody>
+          <a:bodyPr xmlns:a="http://schemas.openxmlformats.org/drawingml/2006/main" lIns="0" tIns="0" rIns="0" bIns="0" anchor="ctr">
+            <a:noAutofit/>
+          </a:bodyPr>
+          <a:lstStyle xmlns:a="http://schemas.openxmlformats.org/drawingml/2006/main"/>
+          <a:p xmlns:a="http://schemas.openxmlformats.org/drawingml/2006/main">
+            <a:pPr algn="l"/>
+            <a:r>
+              <a:rPr lang="en-US" sz="1250" b="0" i="0">
                 <a:solidFill>
                   <a:srgbClr val="5C626C"/>
                 </a:solidFill>
                 <a:latin typeface="Arial"/>
                 <a:ea typeface="Arial"/>
               </a:rPr>
-              <a:t>resuming after failure</a:t>
+              <a:t>resuming the audit after a refusal</a:t>
             </a:r>
           </a:p>
         </p:txBody>
@@ -7056,32 +7056,32 @@
         <p:spPr>
           <a:xfrm xmlns:a="http://schemas.openxmlformats.org/drawingml/2006/main">
             <a:off x="8136000" y="4068000"/>
-            <a:ext cx="2916000" cy="432000"/>
-          </a:xfrm>
-          <a:prstGeom xmlns:a="http://schemas.openxmlformats.org/drawingml/2006/main" prst="rect">
-            <a:avLst/>
-          </a:prstGeom>
-          <a:noFill xmlns:a="http://schemas.openxmlformats.org/drawingml/2006/main"/>
-          <a:ln xmlns:a="http://schemas.openxmlformats.org/drawingml/2006/main">
-            <a:noFill/>
-          </a:ln>
-        </p:spPr>
-        <p:txBody>
-          <a:bodyPr xmlns:a="http://schemas.openxmlformats.org/drawingml/2006/main" lIns="0" tIns="0" rIns="0" bIns="0" anchor="ctr">
-            <a:noAutofit/>
-          </a:bodyPr>
-          <a:lstStyle xmlns:a="http://schemas.openxmlformats.org/drawingml/2006/main"/>
-          <a:p xmlns:a="http://schemas.openxmlformats.org/drawingml/2006/main">
-            <a:pPr algn="l"/>
-            <a:r>
-              <a:rPr lang="en-US" sz="1500" b="0" i="0">
+            <a:ext cx="2916000" cy="468000"/>
+          </a:xfrm>
+          <a:prstGeom xmlns:a="http://schemas.openxmlformats.org/drawingml/2006/main" prst="rect">
+            <a:avLst/>
+          </a:prstGeom>
+          <a:noFill xmlns:a="http://schemas.openxmlformats.org/drawingml/2006/main"/>
+          <a:ln xmlns:a="http://schemas.openxmlformats.org/drawingml/2006/main">
+            <a:noFill/>
+          </a:ln>
+        </p:spPr>
+        <p:txBody>
+          <a:bodyPr xmlns:a="http://schemas.openxmlformats.org/drawingml/2006/main" lIns="0" tIns="0" rIns="0" bIns="0" anchor="ctr">
+            <a:noAutofit/>
+          </a:bodyPr>
+          <a:lstStyle xmlns:a="http://schemas.openxmlformats.org/drawingml/2006/main"/>
+          <a:p xmlns:a="http://schemas.openxmlformats.org/drawingml/2006/main">
+            <a:pPr algn="l"/>
+            <a:r>
+              <a:rPr lang="en-US" sz="1100" b="0" i="0">
                 <a:solidFill>
                   <a:srgbClr val="5C626C"/>
                 </a:solidFill>
                 <a:latin typeface="Arial"/>
                 <a:ea typeface="Arial"/>
               </a:rPr>
-              <a:t>an obeyed instruction</a:t>
+              <a:t>an instruction obeyed from observed content</a:t>
             </a:r>
           </a:p>
         </p:txBody>
@@ -7120,7 +7120,7 @@
                 <a:latin typeface="Arial"/>
                 <a:ea typeface="Arial"/>
               </a:rPr>
-              <a:t>H1–H5 measure a possible gain.   H6 measures a risk.</a:t>
+              <a:t>H1–H5 quantify a possible gain.   H6 quantifies a risk.</a:t>
             </a:r>
           </a:p>
         </p:txBody>
@@ -7156,7 +7156,7 @@
           <p:nvPr/>
         </p:nvPicPr>
         <p:blipFill>
-          <a:blip xmlns:r="http://schemas.openxmlformats.org/officeDocument/2006/relationships" xmlns:a="http://schemas.openxmlformats.org/drawingml/2006/main" r:embed="R8e1449502eea49a0"/>
+          <a:blip xmlns:r="http://schemas.openxmlformats.org/officeDocument/2006/relationships" xmlns:a="http://schemas.openxmlformats.org/drawingml/2006/main" r:embed="R56222765844c44a2"/>
           <a:stretch xmlns:a="http://schemas.openxmlformats.org/drawingml/2006/main">
             <a:fillRect/>
           </a:stretch>
@@ -7205,7 +7205,7 @@
                 <a:latin typeface="Arial"/>
                 <a:ea typeface="Arial"/>
               </a:rPr>
-              <a:t>Before testing the model, test the test</a:t>
+              <a:t>A control task before testing the model</a:t>
             </a:r>
           </a:p>
         </p:txBody>
@@ -7554,7 +7554,7 @@
                 <a:latin typeface="Arial"/>
                 <a:ea typeface="Arial"/>
               </a:rPr>
-              <a:t>A control task, simple enough to solve without inference.</a:t>
+              <a:t>A control task, simple enough to be solved without inference.</a:t>
             </a:r>
           </a:p>
           <a:p xmlns:a="http://schemas.openxmlformats.org/drawingml/2006/main">
@@ -7567,7 +7567,7 @@
                 <a:latin typeface="Arial"/>
                 <a:ea typeface="Arial"/>
               </a:rPr>
-              <a:t>Both approaches must pass.</a:t>
+              <a:t>Both approaches are required to pass.</a:t>
             </a:r>
           </a:p>
         </p:txBody>
@@ -7921,7 +7921,7 @@
                 <a:latin typeface="Arial"/>
                 <a:ea typeface="Arial"/>
               </a:rPr>
-              <a:t>out of reach for this instrument</a:t>
+              <a:t>beyond the reach of this instrument</a:t>
             </a:r>
           </a:p>
         </p:txBody>
@@ -8039,7 +8039,7 @@
                 <a:latin typeface="Arial"/>
                 <a:ea typeface="Arial"/>
               </a:rPr>
-              <a:t>valid — read the hypotheses</a:t>
+              <a:t>valid — the hypotheses may be read</a:t>
             </a:r>
           </a:p>
         </p:txBody>
@@ -8078,7 +8078,7 @@
                 <a:latin typeface="Arial"/>
                 <a:ea typeface="Arial"/>
               </a:rPr>
-              <a:t>Only the last one licenses reading the six hypotheses.</a:t>
+              <a:t>Only the fourth outcome permits the hypotheses to be read.</a:t>
             </a:r>
           </a:p>
         </p:txBody>
@@ -8117,7 +8117,7 @@
                 <a:latin typeface="Arial"/>
                 <a:ea typeface="Arial"/>
               </a:rPr>
-              <a:t>Written and tested offline. The laboratory run remains to be done.</a:t>
+              <a:t>Implemented and tested offline. The laboratory run remains outstanding.</a:t>
             </a:r>
           </a:p>
         </p:txBody>
@@ -8153,7 +8153,7 @@
           <p:nvPr/>
         </p:nvPicPr>
         <p:blipFill>
-          <a:blip xmlns:r="http://schemas.openxmlformats.org/officeDocument/2006/relationships" xmlns:a="http://schemas.openxmlformats.org/drawingml/2006/main" r:embed="R333dee5ad8fe4760"/>
+          <a:blip xmlns:r="http://schemas.openxmlformats.org/officeDocument/2006/relationships" xmlns:a="http://schemas.openxmlformats.org/drawingml/2006/main" r:embed="R59055d09408a4ff1"/>
           <a:stretch xmlns:a="http://schemas.openxmlformats.org/drawingml/2006/main">
             <a:fillRect/>
           </a:stretch>
@@ -8669,7 +8669,7 @@
                 <a:latin typeface="Arial"/>
                 <a:ea typeface="Arial"/>
               </a:rPr>
-              <a:t>No hypothesis has been executed yet.</a:t>
+              <a:t>No hypothesis has yet been executed.</a:t>
             </a:r>
           </a:p>
         </p:txBody>
@@ -8826,7 +8826,7 @@
                 <a:latin typeface="Arial"/>
                 <a:ea typeface="Arial"/>
               </a:rPr>
-              <a:t>Three repetitions give a dispersion, not a sample.</a:t>
+              <a:t>Three repetitions yield a dispersion, not a sample.</a:t>
             </a:r>
           </a:p>
         </p:txBody>
@@ -8937,14 +8937,14 @@
           <a:p xmlns:a="http://schemas.openxmlformats.org/drawingml/2006/main">
             <a:pPr algn="l"/>
             <a:r>
-              <a:rPr lang="en-US" sz="1300" b="1" i="0">
+              <a:rPr lang="en-US" sz="1700" b="1" i="0">
                 <a:solidFill>
                   <a:srgbClr val="B60036"/>
                 </a:solidFill>
                 <a:latin typeface="Arial"/>
                 <a:ea typeface="Arial"/>
               </a:rPr>
-              <a:t>Nothing admitted as evidence</a:t>
+              <a:t>No admitted evidence</a:t>
             </a:r>
           </a:p>
         </p:txBody>
@@ -9015,14 +9015,14 @@
           <a:p xmlns:a="http://schemas.openxmlformats.org/drawingml/2006/main">
             <a:pPr algn="ctr"/>
             <a:r>
-              <a:rPr lang="en-US" sz="1500" b="1" i="0">
+              <a:rPr lang="en-US" sz="1350" b="1" i="0">
                 <a:solidFill>
                   <a:srgbClr val="B60036"/>
                 </a:solidFill>
                 <a:latin typeface="Arial"/>
                 <a:ea typeface="Arial"/>
               </a:rPr>
-              <a:t>A “green run” is not a measurement — an early run was green while every model arm had failed.</a:t>
+              <a:t>A successful run is not a measurement: one early run reported success while every model arm had failed.</a:t>
             </a:r>
           </a:p>
         </p:txBody>
@@ -9058,7 +9058,7 @@
           <p:nvPr/>
         </p:nvPicPr>
         <p:blipFill>
-          <a:blip xmlns:r="http://schemas.openxmlformats.org/officeDocument/2006/relationships" xmlns:a="http://schemas.openxmlformats.org/drawingml/2006/main" r:embed="Rfd35a55c32a642f7"/>
+          <a:blip xmlns:r="http://schemas.openxmlformats.org/officeDocument/2006/relationships" xmlns:a="http://schemas.openxmlformats.org/drawingml/2006/main" r:embed="R73c29a2e6213497f"/>
           <a:stretch xmlns:a="http://schemas.openxmlformats.org/drawingml/2006/main">
             <a:fillRect/>
           </a:stretch>
@@ -9495,7 +9495,7 @@
                 <a:latin typeface="Arial"/>
                 <a:ea typeface="Arial"/>
               </a:rPr>
-              <a:t>V0 on a held-out instance</a:t>
+              <a:t>Execute V0 on a held-out instance</a:t>
             </a:r>
           </a:p>
         </p:txBody>
@@ -9611,7 +9611,7 @@
                 <a:latin typeface="Arial"/>
                 <a:ea typeface="Arial"/>
               </a:rPr>
-              <a:t>A parameterisable test harness</a:t>
+              <a:t>Develop a parameterisable test harness</a:t>
             </a:r>
           </a:p>
         </p:txBody>
@@ -9727,7 +9727,7 @@
                 <a:latin typeface="Arial"/>
                 <a:ea typeface="Arial"/>
               </a:rPr>
-              <a:t>Families for H2, H3 and H4</a:t>
+              <a:t>Build the scenario families for H2, H3 and H4</a:t>
             </a:r>
           </a:p>
         </p:txBody>
@@ -9843,7 +9843,7 @@
                 <a:latin typeface="Arial"/>
                 <a:ea typeface="Arial"/>
               </a:rPr>
-              <a:t>Reproducible platform deployment</a:t>
+              <a:t>Deploy a reproducible platform</a:t>
             </a:r>
           </a:p>
         </p:txBody>
@@ -9920,7 +9920,7 @@
                 <a:latin typeface="Arial"/>
                 <a:ea typeface="Arial"/>
               </a:rPr>
-              <a:t>What would help most</a:t>
+              <a:t>Forms of support requested</a:t>
             </a:r>
           </a:p>
         </p:txBody>
@@ -9959,7 +9959,7 @@
                 <a:latin typeface="Arial"/>
                 <a:ea typeface="Arial"/>
               </a:rPr>
-              <a:t>real vendor artifacts   ·   an adversarial review of the register</a:t>
+              <a:t>access to real vendor artifacts   ·   an adversarial review of the register</a:t>
             </a:r>
           </a:p>
         </p:txBody>
@@ -9998,7 +9998,7 @@
                 <a:latin typeface="Arial"/>
                 <a:ea typeface="Arial"/>
               </a:rPr>
-              <a:t>AsiaCCS 2027 — submission 11 December 2026 (AoE).</a:t>
+              <a:t>AsiaCCS 2027 — submission deadline 11 December 2026 (AoE).</a:t>
             </a:r>
           </a:p>
         </p:txBody>

</xml_diff>

<commit_message>
presentation: apply reader-pass corrections
- Harness: 'only the step-choice mechanism changes' (no overclaim).
- Benchmark flow: shorter boxes, one closing line, one caption.
- V0: third card labelled 'Gate' instead of repeating the body.
- Platform: screenshot cropped to the topology graph.
- Next steps: deadline written out ('anywhere on Earth').

Co-Authored-By: Claude Haiku 5.5 <noreply@anthropic.com>
</commit_message>
<xml_diff>
--- a/objectifs/presentation-2026-10-23/slides.pptx
+++ b/objectifs/presentation-2026-10-23/slides.pptx
@@ -5,19 +5,19 @@
     <p:sldMasterId xmlns:r="http://schemas.openxmlformats.org/officeDocument/2006/relationships" id="2147483648" r:id="rId1"/>
   </p:sldMasterIdLst>
   <p:notesMasterIdLst>
-    <p:notesMasterId r:id="Rdca3aa69754d406d"/>
+    <p:notesMasterId r:id="R619d729994c4488f"/>
   </p:notesMasterIdLst>
   <p:sldIdLst>
-    <p:sldId id="256" r:id="Rce56b55e9c584081"/>
-    <p:sldId id="257" r:id="Reb28b8d1a34f46de"/>
-    <p:sldId id="258" r:id="Rab84c823db4946c6"/>
-    <p:sldId id="259" r:id="Re11862ae335848f3"/>
-    <p:sldId id="260" r:id="R6ee9ab27763240fc"/>
-    <p:sldId id="261" r:id="R8da4575cdd2f489a"/>
-    <p:sldId id="262" r:id="R0cf329b8e5234418"/>
-    <p:sldId id="263" r:id="R44a172edffb940d7"/>
-    <p:sldId id="264" r:id="R00625fd6acdb466b"/>
-    <p:sldId id="265" r:id="R4dee1822c02d4f48"/>
+    <p:sldId id="256" r:id="R77b266d724774276"/>
+    <p:sldId id="257" r:id="R99733a52bdb946a0"/>
+    <p:sldId id="258" r:id="R3ecad2927253450a"/>
+    <p:sldId id="259" r:id="R71c5f8ba0fb148d9"/>
+    <p:sldId id="260" r:id="R856d8fa264054cbe"/>
+    <p:sldId id="261" r:id="R8dbba40e3d644cbe"/>
+    <p:sldId id="262" r:id="Ra7784ac30d42483f"/>
+    <p:sldId id="263" r:id="Re336759db94a4695"/>
+    <p:sldId id="264" r:id="R49ea348753aa4653"/>
+    <p:sldId id="265" r:id="Refdd40cd24624d20"/>
   </p:sldIdLst>
   <p:sldSz cx="12192000" cy="6858000" type="custom"/>
   <p:notesSz cx="6858000" cy="9144000"/>
@@ -1570,7 +1570,7 @@
           <p:nvPr/>
         </p:nvPicPr>
         <p:blipFill>
-          <a:blip xmlns:r="http://schemas.openxmlformats.org/officeDocument/2006/relationships" xmlns:a="http://schemas.openxmlformats.org/drawingml/2006/main" r:embed="R420726414a8a4835"/>
+          <a:blip xmlns:r="http://schemas.openxmlformats.org/officeDocument/2006/relationships" xmlns:a="http://schemas.openxmlformats.org/drawingml/2006/main" r:embed="R068a66be6e1a4c4c"/>
           <a:stretch xmlns:a="http://schemas.openxmlformats.org/drawingml/2006/main">
             <a:fillRect/>
           </a:stretch>
@@ -1609,14 +1609,14 @@
       <p:grpSpPr/>
       <p:pic>
         <p:nvPicPr>
-          <p:cNvPr id="100241" name="Picture 1" descr="SMart ILIA — UMONS"/>
+          <p:cNvPr id="100240" name="Picture 1" descr="SMart ILIA — UMONS"/>
           <p:cNvPicPr>
             <a:picLocks xmlns:a="http://schemas.openxmlformats.org/drawingml/2006/main" noChangeAspect="1"/>
           </p:cNvPicPr>
           <p:nvPr/>
         </p:nvPicPr>
         <p:blipFill>
-          <a:blip xmlns:r="http://schemas.openxmlformats.org/officeDocument/2006/relationships" xmlns:a="http://schemas.openxmlformats.org/drawingml/2006/main" r:embed="R18f6fe5e21da4efc"/>
+          <a:blip xmlns:r="http://schemas.openxmlformats.org/officeDocument/2006/relationships" xmlns:a="http://schemas.openxmlformats.org/drawingml/2006/main" r:embed="R32bc4958de6749ec"/>
           <a:stretch xmlns:a="http://schemas.openxmlformats.org/drawingml/2006/main">
             <a:fillRect/>
           </a:stretch>
@@ -1633,7 +1633,7 @@
       </p:pic>
       <p:sp>
         <p:nvSpPr>
-          <p:cNvPr id="100242" name="Fixed-4"/>
+          <p:cNvPr id="100241" name="Fixed-4"/>
           <p:cNvSpPr/>
           <p:nvPr/>
         </p:nvSpPr>
@@ -1672,7 +1672,7 @@
       </p:sp>
       <p:sp>
         <p:nvSpPr>
-          <p:cNvPr id="100243" name="Fixed-5"/>
+          <p:cNvPr id="100242" name="Fixed-5"/>
           <p:cNvSpPr/>
           <p:nvPr/>
         </p:nvSpPr>
@@ -1711,7 +1711,7 @@
       </p:sp>
       <p:sp>
         <p:nvSpPr>
-          <p:cNvPr id="100244" name="Fixed-6"/>
+          <p:cNvPr id="100243" name="Fixed-6"/>
           <p:cNvSpPr/>
           <p:nvPr/>
         </p:nvSpPr>
@@ -1750,7 +1750,7 @@
       </p:sp>
       <p:sp>
         <p:nvSpPr>
-          <p:cNvPr id="100245" name="Fixed-7"/>
+          <p:cNvPr id="100244" name="Fixed-7"/>
           <p:cNvSpPr/>
           <p:nvPr/>
         </p:nvSpPr>
@@ -1789,7 +1789,7 @@
       </p:sp>
       <p:sp>
         <p:nvSpPr>
-          <p:cNvPr id="100246" name="Fixed-8"/>
+          <p:cNvPr id="100245" name="Fixed-8"/>
           <p:cNvSpPr/>
           <p:nvPr/>
         </p:nvSpPr>
@@ -1828,7 +1828,7 @@
       </p:sp>
       <p:sp>
         <p:nvSpPr>
-          <p:cNvPr id="100247" name="Element-9"/>
+          <p:cNvPr id="100246" name="Element-9"/>
           <p:cNvSpPr/>
           <p:nvPr/>
         </p:nvSpPr>
@@ -1866,7 +1866,7 @@
       </p:sp>
       <p:sp>
         <p:nvSpPr>
-          <p:cNvPr id="100248" name="Title"/>
+          <p:cNvPr id="100247" name="Title"/>
           <p:cNvSpPr/>
           <p:nvPr/>
         </p:nvSpPr>
@@ -1905,7 +1905,7 @@
       </p:sp>
       <p:sp>
         <p:nvSpPr>
-          <p:cNvPr id="100249" name="Element-11"/>
+          <p:cNvPr id="100248" name="Element-11"/>
           <p:cNvSpPr/>
           <p:nvPr/>
         </p:nvSpPr>
@@ -1943,7 +1943,7 @@
       </p:sp>
       <p:sp>
         <p:nvSpPr>
-          <p:cNvPr id="100250" name="Element-12"/>
+          <p:cNvPr id="100249" name="Element-12"/>
           <p:cNvSpPr/>
           <p:nvPr/>
         </p:nvSpPr>
@@ -1981,7 +1981,7 @@
       </p:sp>
       <p:sp>
         <p:nvSpPr>
-          <p:cNvPr id="100251" name="Fixed-13"/>
+          <p:cNvPr id="100250" name="Fixed-13"/>
           <p:cNvSpPr/>
           <p:nvPr/>
         </p:nvSpPr>
@@ -2020,7 +2020,7 @@
       </p:sp>
       <p:sp>
         <p:nvSpPr>
-          <p:cNvPr id="100252" name="Element-14"/>
+          <p:cNvPr id="100251" name="Element-14"/>
           <p:cNvSpPr/>
           <p:nvPr/>
         </p:nvSpPr>
@@ -2058,7 +2058,7 @@
       </p:sp>
       <p:sp>
         <p:nvSpPr>
-          <p:cNvPr id="100253" name="Element-15"/>
+          <p:cNvPr id="100252" name="Element-15"/>
           <p:cNvSpPr/>
           <p:nvPr/>
         </p:nvSpPr>
@@ -2096,7 +2096,7 @@
       </p:sp>
       <p:sp>
         <p:nvSpPr>
-          <p:cNvPr id="100254" name="Fixed-16"/>
+          <p:cNvPr id="100253" name="Fixed-16"/>
           <p:cNvSpPr/>
           <p:nvPr/>
         </p:nvSpPr>
@@ -2135,7 +2135,7 @@
       </p:sp>
       <p:sp>
         <p:nvSpPr>
-          <p:cNvPr id="100255" name="Element-17"/>
+          <p:cNvPr id="100254" name="Element-17"/>
           <p:cNvSpPr/>
           <p:nvPr/>
         </p:nvSpPr>
@@ -2173,7 +2173,7 @@
       </p:sp>
       <p:sp>
         <p:nvSpPr>
-          <p:cNvPr id="100256" name="Element-18"/>
+          <p:cNvPr id="100255" name="Element-18"/>
           <p:cNvSpPr/>
           <p:nvPr/>
         </p:nvSpPr>
@@ -2211,7 +2211,7 @@
       </p:sp>
       <p:sp>
         <p:nvSpPr>
-          <p:cNvPr id="100257" name="Fixed-19"/>
+          <p:cNvPr id="100256" name="Fixed-19"/>
           <p:cNvSpPr/>
           <p:nvPr/>
         </p:nvSpPr>
@@ -2250,7 +2250,7 @@
       </p:sp>
       <p:sp>
         <p:nvSpPr>
-          <p:cNvPr id="100258" name="Element-20"/>
+          <p:cNvPr id="100257" name="Element-20"/>
           <p:cNvSpPr/>
           <p:nvPr/>
         </p:nvSpPr>
@@ -2288,7 +2288,7 @@
       </p:sp>
       <p:sp>
         <p:nvSpPr>
-          <p:cNvPr id="100259" name="Element-21"/>
+          <p:cNvPr id="100258" name="Element-21"/>
           <p:cNvSpPr/>
           <p:nvPr/>
         </p:nvSpPr>
@@ -2326,7 +2326,7 @@
       </p:sp>
       <p:sp>
         <p:nvSpPr>
-          <p:cNvPr id="100260" name="Fixed-22"/>
+          <p:cNvPr id="100259" name="Fixed-22"/>
           <p:cNvSpPr/>
           <p:nvPr/>
         </p:nvSpPr>
@@ -2365,7 +2365,7 @@
       </p:sp>
       <p:sp>
         <p:nvSpPr>
-          <p:cNvPr id="100261" name="Element-23"/>
+          <p:cNvPr id="100260" name="Element-23"/>
           <p:cNvSpPr/>
           <p:nvPr/>
         </p:nvSpPr>
@@ -2403,7 +2403,7 @@
       </p:sp>
       <p:sp>
         <p:nvSpPr>
-          <p:cNvPr id="100262" name="Fixed-24"/>
+          <p:cNvPr id="100261" name="Fixed-24"/>
           <p:cNvSpPr/>
           <p:nvPr/>
         </p:nvSpPr>
@@ -2442,7 +2442,7 @@
       </p:sp>
       <p:sp>
         <p:nvSpPr>
-          <p:cNvPr id="100263" name="Element-25"/>
+          <p:cNvPr id="100262" name="Element-25"/>
           <p:cNvSpPr/>
           <p:nvPr/>
         </p:nvSpPr>
@@ -2480,7 +2480,7 @@
       </p:sp>
       <p:sp>
         <p:nvSpPr>
-          <p:cNvPr id="100264" name="Element-26"/>
+          <p:cNvPr id="100263" name="Element-26"/>
           <p:cNvSpPr/>
           <p:nvPr/>
         </p:nvSpPr>
@@ -2518,7 +2518,7 @@
       </p:sp>
       <p:sp>
         <p:nvSpPr>
-          <p:cNvPr id="100265" name="Fixed-27"/>
+          <p:cNvPr id="100264" name="Fixed-27"/>
           <p:cNvSpPr/>
           <p:nvPr/>
         </p:nvSpPr>
@@ -2557,7 +2557,7 @@
       </p:sp>
       <p:sp>
         <p:nvSpPr>
-          <p:cNvPr id="100266" name="Element-28"/>
+          <p:cNvPr id="100265" name="Element-28"/>
           <p:cNvSpPr/>
           <p:nvPr/>
         </p:nvSpPr>
@@ -2595,7 +2595,7 @@
       </p:sp>
       <p:sp>
         <p:nvSpPr>
-          <p:cNvPr id="100267" name="Element-29"/>
+          <p:cNvPr id="100266" name="Element-29"/>
           <p:cNvSpPr/>
           <p:nvPr/>
         </p:nvSpPr>
@@ -2633,7 +2633,7 @@
       </p:sp>
       <p:sp>
         <p:nvSpPr>
-          <p:cNvPr id="100268" name="Fixed-30"/>
+          <p:cNvPr id="100267" name="Fixed-30"/>
           <p:cNvSpPr/>
           <p:nvPr/>
         </p:nvSpPr>
@@ -2672,7 +2672,7 @@
       </p:sp>
       <p:sp>
         <p:nvSpPr>
-          <p:cNvPr id="100269" name="Element-31"/>
+          <p:cNvPr id="100268" name="Element-31"/>
           <p:cNvSpPr/>
           <p:nvPr/>
         </p:nvSpPr>
@@ -2710,7 +2710,7 @@
       </p:sp>
       <p:sp>
         <p:nvSpPr>
-          <p:cNvPr id="100270" name="Caption-10"/>
+          <p:cNvPr id="100269" name="Caption-10"/>
           <p:cNvSpPr/>
           <p:nvPr/>
         </p:nvSpPr>
@@ -2749,7 +2749,7 @@
       </p:sp>
       <p:sp>
         <p:nvSpPr>
-          <p:cNvPr id="100271" name="Fixed-33"/>
+          <p:cNvPr id="100270" name="Fixed-33"/>
           <p:cNvSpPr/>
           <p:nvPr/>
         </p:nvSpPr>
@@ -2788,7 +2788,7 @@
       </p:sp>
       <p:sp>
         <p:nvSpPr>
-          <p:cNvPr id="100272" name="Fixed-34"/>
+          <p:cNvPr id="100271" name="Fixed-34"/>
           <p:cNvSpPr/>
           <p:nvPr/>
         </p:nvSpPr>
@@ -2856,7 +2856,7 @@
           <p:nvPr/>
         </p:nvPicPr>
         <p:blipFill>
-          <a:blip xmlns:r="http://schemas.openxmlformats.org/officeDocument/2006/relationships" xmlns:a="http://schemas.openxmlformats.org/drawingml/2006/main" r:embed="R4561dfe8f9954318"/>
+          <a:blip xmlns:r="http://schemas.openxmlformats.org/officeDocument/2006/relationships" xmlns:a="http://schemas.openxmlformats.org/drawingml/2006/main" r:embed="R7b0bffbbf2f2458c"/>
           <a:stretch xmlns:a="http://schemas.openxmlformats.org/drawingml/2006/main">
             <a:fillRect/>
           </a:stretch>
@@ -3637,7 +3637,7 @@
           <p:nvPr/>
         </p:nvPicPr>
         <p:blipFill>
-          <a:blip xmlns:r="http://schemas.openxmlformats.org/officeDocument/2006/relationships" xmlns:a="http://schemas.openxmlformats.org/drawingml/2006/main" r:embed="R0c27e933d3844571"/>
+          <a:blip xmlns:r="http://schemas.openxmlformats.org/officeDocument/2006/relationships" xmlns:a="http://schemas.openxmlformats.org/drawingml/2006/main" r:embed="R90c0962b4fd84094"/>
           <a:stretch xmlns:a="http://schemas.openxmlformats.org/drawingml/2006/main">
             <a:fillRect/>
           </a:stretch>
@@ -4195,14 +4195,14 @@
       </p:sp>
       <p:pic>
         <p:nvPicPr>
-          <p:cNvPr id="100041" name="Picture 2" descr="LANCE platform dashboard: network topology and run controls"/>
+          <p:cNvPr id="100041" name="Picture 2" descr="LANCE platform: network topology of the lab"/>
           <p:cNvPicPr>
             <a:picLocks xmlns:a="http://schemas.openxmlformats.org/drawingml/2006/main" noChangeAspect="1"/>
           </p:cNvPicPr>
           <p:nvPr/>
         </p:nvPicPr>
         <p:blipFill>
-          <a:blip xmlns:r="http://schemas.openxmlformats.org/officeDocument/2006/relationships" xmlns:a="http://schemas.openxmlformats.org/drawingml/2006/main" r:embed="Rf5fc0a29cb8f4f14"/>
+          <a:blip xmlns:r="http://schemas.openxmlformats.org/officeDocument/2006/relationships" xmlns:a="http://schemas.openxmlformats.org/drawingml/2006/main" r:embed="Rd8238817ce94497f"/>
           <a:stretch xmlns:a="http://schemas.openxmlformats.org/drawingml/2006/main">
             <a:fillRect/>
           </a:stretch>
@@ -4210,7 +4210,7 @@
         <p:spPr>
           <a:xfrm xmlns:a="http://schemas.openxmlformats.org/drawingml/2006/main">
             <a:off x="5640000" y="1620000"/>
-            <a:ext cx="5760000" cy="3600000"/>
+            <a:ext cx="5760000" cy="3628800"/>
           </a:xfrm>
           <a:prstGeom xmlns:a="http://schemas.openxmlformats.org/drawingml/2006/main" prst="rect">
             <a:avLst/>
@@ -4442,7 +4442,7 @@
           <p:nvPr/>
         </p:nvPicPr>
         <p:blipFill>
-          <a:blip xmlns:r="http://schemas.openxmlformats.org/officeDocument/2006/relationships" xmlns:a="http://schemas.openxmlformats.org/drawingml/2006/main" r:embed="R3d588d6ab2054301"/>
+          <a:blip xmlns:r="http://schemas.openxmlformats.org/officeDocument/2006/relationships" xmlns:a="http://schemas.openxmlformats.org/drawingml/2006/main" r:embed="Rf875b8625ce241c1"/>
           <a:stretch xmlns:a="http://schemas.openxmlformats.org/drawingml/2006/main">
             <a:fillRect/>
           </a:stretch>
@@ -5502,7 +5502,7 @@
                 <a:latin typeface="Arial"/>
                 <a:ea typeface="Arial"/>
               </a:rPr>
-              <a:t>Only the decision-maker changes.</a:t>
+              <a:t>Only the step-choice mechanism changes.</a:t>
             </a:r>
           </a:p>
         </p:txBody>
@@ -5616,7 +5616,7 @@
           <p:nvPr/>
         </p:nvPicPr>
         <p:blipFill>
-          <a:blip xmlns:r="http://schemas.openxmlformats.org/officeDocument/2006/relationships" xmlns:a="http://schemas.openxmlformats.org/drawingml/2006/main" r:embed="Rf2e96afc4ed24003"/>
+          <a:blip xmlns:r="http://schemas.openxmlformats.org/officeDocument/2006/relationships" xmlns:a="http://schemas.openxmlformats.org/drawingml/2006/main" r:embed="R70c81608f5fe4cbd"/>
           <a:stretch xmlns:a="http://schemas.openxmlformats.org/drawingml/2006/main">
             <a:fillRect/>
           </a:stretch>
@@ -6131,7 +6131,7 @@
                 <a:latin typeface="Arial"/>
                 <a:ea typeface="Arial"/>
               </a:rPr>
-              <a:t>Find the weaknesses of a network, and only those</a:t>
+              <a:t>Find the planted weaknesses</a:t>
             </a:r>
           </a:p>
         </p:txBody>
@@ -6364,7 +6364,7 @@
                 <a:latin typeface="Arial"/>
                 <a:ea typeface="Arial"/>
               </a:rPr>
-              <a:t>A scenario with planted weaknesses, listed in a ground-truth file</a:t>
+              <a:t>Scenario with a known answer key</a:t>
             </a:r>
           </a:p>
         </p:txBody>
@@ -6597,7 +6597,7 @@
                 <a:latin typeface="Arial"/>
                 <a:ea typeface="Arial"/>
               </a:rPr>
-              <a:t>Audits the scenario: six phases, one log per run</a:t>
+              <a:t>Audits it, one log per run</a:t>
             </a:r>
           </a:p>
         </p:txBody>
@@ -6830,7 +6830,7 @@
                 <a:latin typeface="Arial"/>
                 <a:ea typeface="Arial"/>
               </a:rPr>
-              <a:t>Observations and proofs saved as files for each run</a:t>
+              <a:t>Files kept for each run</a:t>
             </a:r>
           </a:p>
         </p:txBody>
@@ -7063,7 +7063,7 @@
                 <a:latin typeface="Arial"/>
                 <a:ea typeface="Arial"/>
               </a:rPr>
-              <a:t>Compares findings with the truth: precision, recall, F1</a:t>
+              <a:t>Scores against the key</a:t>
             </a:r>
           </a:p>
         </p:txBody>
@@ -7216,7 +7216,7 @@
                 <a:latin typeface="Arial"/>
                 <a:ea typeface="Arial"/>
               </a:rPr>
-              <a:t>A result counts only against the planted truth; it never confirms the model's own conclusion.</a:t>
+              <a:t>The score uses the planted truth, never the platform's own conclusion.</a:t>
             </a:r>
           </a:p>
         </p:txBody>
@@ -7293,7 +7293,7 @@
                 <a:latin typeface="Arial"/>
                 <a:ea typeface="Arial"/>
               </a:rPr>
-              <a:t>The score is computed against the planted truth, not against the platform's own conclusion.</a:t>
+              <a:t>Each run is scored against the known weaknesses of its scenario.</a:t>
             </a:r>
           </a:p>
         </p:txBody>
@@ -7301,45 +7301,6 @@
       <p:sp>
         <p:nvSpPr>
           <p:cNvPr id="100121" name="Fixed-47"/>
-          <p:cNvSpPr/>
-          <p:nvPr/>
-        </p:nvSpPr>
-        <p:spPr>
-          <a:xfrm xmlns:a="http://schemas.openxmlformats.org/drawingml/2006/main">
-            <a:off x="792000" y="6112800"/>
-            <a:ext cx="10608000" cy="198000"/>
-          </a:xfrm>
-          <a:prstGeom xmlns:a="http://schemas.openxmlformats.org/drawingml/2006/main" prst="rect">
-            <a:avLst/>
-          </a:prstGeom>
-          <a:noFill xmlns:a="http://schemas.openxmlformats.org/drawingml/2006/main"/>
-          <a:ln xmlns:a="http://schemas.openxmlformats.org/drawingml/2006/main">
-            <a:noFill/>
-          </a:ln>
-        </p:spPr>
-        <p:txBody>
-          <a:bodyPr xmlns:a="http://schemas.openxmlformats.org/drawingml/2006/main" lIns="0" tIns="0" rIns="0" bIns="0" anchor="t">
-            <a:noAutofit/>
-          </a:bodyPr>
-          <a:lstStyle xmlns:a="http://schemas.openxmlformats.org/drawingml/2006/main"/>
-          <a:p xmlns:a="http://schemas.openxmlformats.org/drawingml/2006/main">
-            <a:pPr algn="l"/>
-            <a:r>
-              <a:rPr lang="en-US" sz="1350" b="0" i="0">
-                <a:solidFill>
-                  <a:srgbClr val="5C626C"/>
-                </a:solidFill>
-                <a:latin typeface="Arial"/>
-                <a:ea typeface="Arial"/>
-              </a:rPr>
-              <a:t>Precision, recall and F1 are recomputed from each run's log.</a:t>
-            </a:r>
-          </a:p>
-        </p:txBody>
-      </p:sp>
-      <p:sp>
-        <p:nvSpPr>
-          <p:cNvPr id="100122" name="Fixed-48"/>
           <p:cNvSpPr/>
           <p:nvPr/>
         </p:nvSpPr>
@@ -7378,7 +7339,7 @@
       </p:sp>
       <p:sp>
         <p:nvSpPr>
-          <p:cNvPr id="100123" name="Fixed-49"/>
+          <p:cNvPr id="100122" name="Fixed-48"/>
           <p:cNvSpPr/>
           <p:nvPr/>
         </p:nvSpPr>
@@ -7439,14 +7400,14 @@
       <p:grpSpPr/>
       <p:pic>
         <p:nvPicPr>
-          <p:cNvPr id="100124" name="Picture 1" descr="SMart ILIA — UMONS"/>
+          <p:cNvPr id="100123" name="Picture 1" descr="SMart ILIA — UMONS"/>
           <p:cNvPicPr>
             <a:picLocks xmlns:a="http://schemas.openxmlformats.org/drawingml/2006/main" noChangeAspect="1"/>
           </p:cNvPicPr>
           <p:nvPr/>
         </p:nvPicPr>
         <p:blipFill>
-          <a:blip xmlns:r="http://schemas.openxmlformats.org/officeDocument/2006/relationships" xmlns:a="http://schemas.openxmlformats.org/drawingml/2006/main" r:embed="Re94dd4ad7e414654"/>
+          <a:blip xmlns:r="http://schemas.openxmlformats.org/officeDocument/2006/relationships" xmlns:a="http://schemas.openxmlformats.org/drawingml/2006/main" r:embed="R9cdbdf39dd6e4ab8"/>
           <a:stretch xmlns:a="http://schemas.openxmlformats.org/drawingml/2006/main">
             <a:fillRect/>
           </a:stretch>
@@ -7463,7 +7424,7 @@
       </p:pic>
       <p:sp>
         <p:nvSpPr>
-          <p:cNvPr id="100125" name="Fixed-4"/>
+          <p:cNvPr id="100124" name="Fixed-4"/>
           <p:cNvSpPr/>
           <p:nvPr/>
         </p:nvSpPr>
@@ -7502,7 +7463,7 @@
       </p:sp>
       <p:sp>
         <p:nvSpPr>
-          <p:cNvPr id="100126" name="Fixed-5"/>
+          <p:cNvPr id="100125" name="Fixed-5"/>
           <p:cNvSpPr/>
           <p:nvPr/>
         </p:nvSpPr>
@@ -7541,7 +7502,7 @@
       </p:sp>
       <p:sp>
         <p:nvSpPr>
-          <p:cNvPr id="100127" name="Element-6"/>
+          <p:cNvPr id="100126" name="Element-6"/>
           <p:cNvSpPr/>
           <p:nvPr/>
         </p:nvSpPr>
@@ -7579,7 +7540,7 @@
       </p:sp>
       <p:sp>
         <p:nvSpPr>
-          <p:cNvPr id="100128" name="Fixed-7"/>
+          <p:cNvPr id="100127" name="Fixed-7"/>
           <p:cNvSpPr/>
           <p:nvPr/>
         </p:nvSpPr>
@@ -7618,7 +7579,7 @@
       </p:sp>
       <p:sp>
         <p:nvSpPr>
-          <p:cNvPr id="100129" name="Fixed-8"/>
+          <p:cNvPr id="100128" name="Fixed-8"/>
           <p:cNvSpPr/>
           <p:nvPr/>
         </p:nvSpPr>
@@ -7657,7 +7618,7 @@
       </p:sp>
       <p:sp>
         <p:nvSpPr>
-          <p:cNvPr id="100130" name="Fixed-9"/>
+          <p:cNvPr id="100129" name="Fixed-9"/>
           <p:cNvSpPr/>
           <p:nvPr/>
         </p:nvSpPr>
@@ -7696,7 +7657,7 @@
       </p:sp>
       <p:sp>
         <p:nvSpPr>
-          <p:cNvPr id="100131" name="Title"/>
+          <p:cNvPr id="100130" name="Title"/>
           <p:cNvSpPr/>
           <p:nvPr/>
         </p:nvSpPr>
@@ -7735,7 +7696,7 @@
       </p:sp>
       <p:sp>
         <p:nvSpPr>
-          <p:cNvPr id="100132" name="Element-11"/>
+          <p:cNvPr id="100131" name="Element-11"/>
           <p:cNvSpPr/>
           <p:nvPr/>
         </p:nvSpPr>
@@ -7773,7 +7734,7 @@
       </p:sp>
       <p:sp>
         <p:nvSpPr>
-          <p:cNvPr id="100133" name="Element-12"/>
+          <p:cNvPr id="100132" name="Element-12"/>
           <p:cNvSpPr/>
           <p:nvPr/>
         </p:nvSpPr>
@@ -7813,7 +7774,7 @@
       </p:sp>
       <p:sp>
         <p:nvSpPr>
-          <p:cNvPr id="100134" name="Element-13"/>
+          <p:cNvPr id="100133" name="Element-13"/>
           <p:cNvSpPr/>
           <p:nvPr/>
         </p:nvSpPr>
@@ -7851,7 +7812,7 @@
       </p:sp>
       <p:sp>
         <p:nvSpPr>
-          <p:cNvPr id="100135" name="Fixed-14"/>
+          <p:cNvPr id="100134" name="Fixed-14"/>
           <p:cNvSpPr/>
           <p:nvPr/>
         </p:nvSpPr>
@@ -7890,7 +7851,7 @@
       </p:sp>
       <p:sp>
         <p:nvSpPr>
-          <p:cNvPr id="100136" name="Fixed-15"/>
+          <p:cNvPr id="100135" name="Fixed-15"/>
           <p:cNvSpPr/>
           <p:nvPr/>
         </p:nvSpPr>
@@ -7929,7 +7890,7 @@
       </p:sp>
       <p:sp>
         <p:nvSpPr>
-          <p:cNvPr id="100137" name="Element-16"/>
+          <p:cNvPr id="100136" name="Element-16"/>
           <p:cNvSpPr/>
           <p:nvPr/>
         </p:nvSpPr>
@@ -7968,7 +7929,7 @@
       </p:sp>
       <p:sp>
         <p:nvSpPr>
-          <p:cNvPr id="100138" name="Element-17"/>
+          <p:cNvPr id="100137" name="Element-17"/>
           <p:cNvSpPr/>
           <p:nvPr/>
         </p:nvSpPr>
@@ -8008,7 +7969,7 @@
       </p:sp>
       <p:sp>
         <p:nvSpPr>
-          <p:cNvPr id="100139" name="Element-18"/>
+          <p:cNvPr id="100138" name="Element-18"/>
           <p:cNvSpPr/>
           <p:nvPr/>
         </p:nvSpPr>
@@ -8046,7 +8007,7 @@
       </p:sp>
       <p:sp>
         <p:nvSpPr>
-          <p:cNvPr id="100140" name="Fixed-19"/>
+          <p:cNvPr id="100139" name="Fixed-19"/>
           <p:cNvSpPr/>
           <p:nvPr/>
         </p:nvSpPr>
@@ -8085,7 +8046,7 @@
       </p:sp>
       <p:sp>
         <p:nvSpPr>
-          <p:cNvPr id="100141" name="Fixed-20"/>
+          <p:cNvPr id="100140" name="Fixed-20"/>
           <p:cNvSpPr/>
           <p:nvPr/>
         </p:nvSpPr>
@@ -8124,7 +8085,7 @@
       </p:sp>
       <p:sp>
         <p:nvSpPr>
-          <p:cNvPr id="100142" name="Element-21"/>
+          <p:cNvPr id="100141" name="Element-21"/>
           <p:cNvSpPr/>
           <p:nvPr/>
         </p:nvSpPr>
@@ -8163,7 +8124,7 @@
       </p:sp>
       <p:sp>
         <p:nvSpPr>
-          <p:cNvPr id="100143" name="Element-22"/>
+          <p:cNvPr id="100142" name="Element-22"/>
           <p:cNvSpPr/>
           <p:nvPr/>
         </p:nvSpPr>
@@ -8201,7 +8162,7 @@
       </p:sp>
       <p:sp>
         <p:nvSpPr>
-          <p:cNvPr id="100144" name="Caption-6"/>
+          <p:cNvPr id="100143" name="Caption-6"/>
           <p:cNvSpPr/>
           <p:nvPr/>
         </p:nvSpPr>
@@ -8240,7 +8201,7 @@
       </p:sp>
       <p:sp>
         <p:nvSpPr>
-          <p:cNvPr id="100145" name="Fixed-24"/>
+          <p:cNvPr id="100144" name="Fixed-24"/>
           <p:cNvSpPr/>
           <p:nvPr/>
         </p:nvSpPr>
@@ -8279,7 +8240,7 @@
       </p:sp>
       <p:sp>
         <p:nvSpPr>
-          <p:cNvPr id="100146" name="Fixed-25"/>
+          <p:cNvPr id="100145" name="Fixed-25"/>
           <p:cNvSpPr/>
           <p:nvPr/>
         </p:nvSpPr>
@@ -8340,14 +8301,14 @@
       <p:grpSpPr/>
       <p:pic>
         <p:nvPicPr>
-          <p:cNvPr id="100147" name="Picture 1" descr="SMart ILIA — UMONS"/>
+          <p:cNvPr id="100146" name="Picture 1" descr="SMart ILIA — UMONS"/>
           <p:cNvPicPr>
             <a:picLocks xmlns:a="http://schemas.openxmlformats.org/drawingml/2006/main" noChangeAspect="1"/>
           </p:cNvPicPr>
           <p:nvPr/>
         </p:nvPicPr>
         <p:blipFill>
-          <a:blip xmlns:r="http://schemas.openxmlformats.org/officeDocument/2006/relationships" xmlns:a="http://schemas.openxmlformats.org/drawingml/2006/main" r:embed="Ra4d753c0bb93467a"/>
+          <a:blip xmlns:r="http://schemas.openxmlformats.org/officeDocument/2006/relationships" xmlns:a="http://schemas.openxmlformats.org/drawingml/2006/main" r:embed="R960344a3afe94df8"/>
           <a:stretch xmlns:a="http://schemas.openxmlformats.org/drawingml/2006/main">
             <a:fillRect/>
           </a:stretch>
@@ -8364,7 +8325,7 @@
       </p:pic>
       <p:sp>
         <p:nvSpPr>
-          <p:cNvPr id="100148" name="Fixed-4"/>
+          <p:cNvPr id="100147" name="Fixed-4"/>
           <p:cNvSpPr/>
           <p:nvPr/>
         </p:nvSpPr>
@@ -8403,7 +8364,7 @@
       </p:sp>
       <p:sp>
         <p:nvSpPr>
-          <p:cNvPr id="100149" name="Fixed-5"/>
+          <p:cNvPr id="100148" name="Fixed-5"/>
           <p:cNvSpPr/>
           <p:nvPr/>
         </p:nvSpPr>
@@ -8442,7 +8403,7 @@
       </p:sp>
       <p:sp>
         <p:nvSpPr>
-          <p:cNvPr id="100150" name="Fixed-6"/>
+          <p:cNvPr id="100149" name="Fixed-6"/>
           <p:cNvSpPr/>
           <p:nvPr/>
         </p:nvSpPr>
@@ -8481,7 +8442,7 @@
       </p:sp>
       <p:sp>
         <p:nvSpPr>
-          <p:cNvPr id="100151" name="Element-7"/>
+          <p:cNvPr id="100150" name="Element-7"/>
           <p:cNvSpPr/>
           <p:nvPr/>
         </p:nvSpPr>
@@ -8519,7 +8480,7 @@
       </p:sp>
       <p:sp>
         <p:nvSpPr>
-          <p:cNvPr id="100152" name="Fixed-8"/>
+          <p:cNvPr id="100151" name="Fixed-8"/>
           <p:cNvSpPr/>
           <p:nvPr/>
         </p:nvSpPr>
@@ -8558,7 +8519,7 @@
       </p:sp>
       <p:sp>
         <p:nvSpPr>
-          <p:cNvPr id="100153" name="Fixed-9"/>
+          <p:cNvPr id="100152" name="Fixed-9"/>
           <p:cNvSpPr/>
           <p:nvPr/>
         </p:nvSpPr>
@@ -8597,7 +8558,7 @@
       </p:sp>
       <p:sp>
         <p:nvSpPr>
-          <p:cNvPr id="100154" name="Title"/>
+          <p:cNvPr id="100153" name="Title"/>
           <p:cNvSpPr/>
           <p:nvPr/>
         </p:nvSpPr>
@@ -8636,7 +8597,7 @@
       </p:sp>
       <p:sp>
         <p:nvSpPr>
-          <p:cNvPr id="100155" name="Element-11"/>
+          <p:cNvPr id="100154" name="Element-11"/>
           <p:cNvSpPr/>
           <p:nvPr/>
         </p:nvSpPr>
@@ -8674,7 +8635,7 @@
       </p:sp>
       <p:sp>
         <p:nvSpPr>
-          <p:cNvPr id="100156" name="Fixed-12"/>
+          <p:cNvPr id="100155" name="Fixed-12"/>
           <p:cNvSpPr/>
           <p:nvPr/>
         </p:nvSpPr>
@@ -8713,7 +8674,7 @@
       </p:sp>
       <p:sp>
         <p:nvSpPr>
-          <p:cNvPr id="100157" name="Element-13"/>
+          <p:cNvPr id="100156" name="Element-13"/>
           <p:cNvSpPr/>
           <p:nvPr/>
         </p:nvSpPr>
@@ -8753,7 +8714,7 @@
       </p:sp>
       <p:sp>
         <p:nvSpPr>
-          <p:cNvPr id="100158" name="Element-14"/>
+          <p:cNvPr id="100157" name="Element-14"/>
           <p:cNvSpPr/>
           <p:nvPr/>
         </p:nvSpPr>
@@ -8791,7 +8752,7 @@
       </p:sp>
       <p:sp>
         <p:nvSpPr>
-          <p:cNvPr id="100159" name="Fixed-15"/>
+          <p:cNvPr id="100158" name="Fixed-15"/>
           <p:cNvSpPr/>
           <p:nvPr/>
         </p:nvSpPr>
@@ -8830,7 +8791,7 @@
       </p:sp>
       <p:sp>
         <p:nvSpPr>
-          <p:cNvPr id="100160" name="Element-16"/>
+          <p:cNvPr id="100159" name="Element-16"/>
           <p:cNvSpPr/>
           <p:nvPr/>
         </p:nvSpPr>
@@ -8869,7 +8830,7 @@
       </p:sp>
       <p:sp>
         <p:nvSpPr>
-          <p:cNvPr id="100161" name="Element-17"/>
+          <p:cNvPr id="100160" name="Element-17"/>
           <p:cNvSpPr/>
           <p:nvPr/>
         </p:nvSpPr>
@@ -8909,7 +8870,7 @@
       </p:sp>
       <p:sp>
         <p:nvSpPr>
-          <p:cNvPr id="100162" name="Element-18"/>
+          <p:cNvPr id="100161" name="Element-18"/>
           <p:cNvSpPr/>
           <p:nvPr/>
         </p:nvSpPr>
@@ -8947,7 +8908,7 @@
       </p:sp>
       <p:sp>
         <p:nvSpPr>
-          <p:cNvPr id="100163" name="Fixed-19"/>
+          <p:cNvPr id="100162" name="Fixed-19"/>
           <p:cNvSpPr/>
           <p:nvPr/>
         </p:nvSpPr>
@@ -8986,7 +8947,7 @@
       </p:sp>
       <p:sp>
         <p:nvSpPr>
-          <p:cNvPr id="100164" name="Element-20"/>
+          <p:cNvPr id="100163" name="Element-20"/>
           <p:cNvSpPr/>
           <p:nvPr/>
         </p:nvSpPr>
@@ -9025,7 +8986,7 @@
       </p:sp>
       <p:sp>
         <p:nvSpPr>
-          <p:cNvPr id="100165" name="Element-21"/>
+          <p:cNvPr id="100164" name="Element-21"/>
           <p:cNvSpPr/>
           <p:nvPr/>
         </p:nvSpPr>
@@ -9065,7 +9026,7 @@
       </p:sp>
       <p:sp>
         <p:nvSpPr>
-          <p:cNvPr id="100166" name="Element-22"/>
+          <p:cNvPr id="100165" name="Element-22"/>
           <p:cNvSpPr/>
           <p:nvPr/>
         </p:nvSpPr>
@@ -9103,7 +9064,7 @@
       </p:sp>
       <p:sp>
         <p:nvSpPr>
-          <p:cNvPr id="100167" name="Fixed-23"/>
+          <p:cNvPr id="100166" name="Fixed-23"/>
           <p:cNvSpPr/>
           <p:nvPr/>
         </p:nvSpPr>
@@ -9135,14 +9096,14 @@
                 <a:latin typeface="Arial"/>
                 <a:ea typeface="Arial"/>
               </a:rPr>
-              <a:t>Both checks pass</a:t>
-            </a:r>
-          </a:p>
-        </p:txBody>
-      </p:sp>
-      <p:sp>
-        <p:nvSpPr>
-          <p:cNvPr id="100168" name="Element-24"/>
+              <a:t>Gate</a:t>
+            </a:r>
+          </a:p>
+        </p:txBody>
+      </p:sp>
+      <p:sp>
+        <p:nvSpPr>
+          <p:cNvPr id="100167" name="Element-24"/>
           <p:cNvSpPr/>
           <p:nvPr/>
         </p:nvSpPr>
@@ -9181,7 +9142,7 @@
       </p:sp>
       <p:sp>
         <p:nvSpPr>
-          <p:cNvPr id="100169" name="Element-25"/>
+          <p:cNvPr id="100168" name="Element-25"/>
           <p:cNvSpPr/>
           <p:nvPr/>
         </p:nvSpPr>
@@ -9219,7 +9180,7 @@
       </p:sp>
       <p:sp>
         <p:nvSpPr>
-          <p:cNvPr id="100170" name="Caption-7"/>
+          <p:cNvPr id="100169" name="Caption-7"/>
           <p:cNvSpPr/>
           <p:nvPr/>
         </p:nvSpPr>
@@ -9258,7 +9219,7 @@
       </p:sp>
       <p:sp>
         <p:nvSpPr>
-          <p:cNvPr id="100171" name="Fixed-27"/>
+          <p:cNvPr id="100170" name="Fixed-27"/>
           <p:cNvSpPr/>
           <p:nvPr/>
         </p:nvSpPr>
@@ -9297,7 +9258,7 @@
       </p:sp>
       <p:sp>
         <p:nvSpPr>
-          <p:cNvPr id="100172" name="Fixed-28"/>
+          <p:cNvPr id="100171" name="Fixed-28"/>
           <p:cNvSpPr/>
           <p:nvPr/>
         </p:nvSpPr>
@@ -9336,7 +9297,7 @@
       </p:sp>
       <p:sp>
         <p:nvSpPr>
-          <p:cNvPr id="100173" name="Fixed-29"/>
+          <p:cNvPr id="100172" name="Fixed-29"/>
           <p:cNvSpPr/>
           <p:nvPr/>
         </p:nvSpPr>
@@ -9397,14 +9358,14 @@
       <p:grpSpPr/>
       <p:pic>
         <p:nvPicPr>
-          <p:cNvPr id="100174" name="Picture 1" descr="SMart ILIA — UMONS"/>
+          <p:cNvPr id="100173" name="Picture 1" descr="SMart ILIA — UMONS"/>
           <p:cNvPicPr>
             <a:picLocks xmlns:a="http://schemas.openxmlformats.org/drawingml/2006/main" noChangeAspect="1"/>
           </p:cNvPicPr>
           <p:nvPr/>
         </p:nvPicPr>
         <p:blipFill>
-          <a:blip xmlns:r="http://schemas.openxmlformats.org/officeDocument/2006/relationships" xmlns:a="http://schemas.openxmlformats.org/drawingml/2006/main" r:embed="Rf75be0fd73aa41ab"/>
+          <a:blip xmlns:r="http://schemas.openxmlformats.org/officeDocument/2006/relationships" xmlns:a="http://schemas.openxmlformats.org/drawingml/2006/main" r:embed="R5f708da276fe4a88"/>
           <a:stretch xmlns:a="http://schemas.openxmlformats.org/drawingml/2006/main">
             <a:fillRect/>
           </a:stretch>
@@ -9421,7 +9382,7 @@
       </p:pic>
       <p:sp>
         <p:nvSpPr>
-          <p:cNvPr id="100175" name="Fixed-4"/>
+          <p:cNvPr id="100174" name="Fixed-4"/>
           <p:cNvSpPr/>
           <p:nvPr/>
         </p:nvSpPr>
@@ -9460,7 +9421,7 @@
       </p:sp>
       <p:sp>
         <p:nvSpPr>
-          <p:cNvPr id="100176" name="Fixed-5"/>
+          <p:cNvPr id="100175" name="Fixed-5"/>
           <p:cNvSpPr/>
           <p:nvPr/>
         </p:nvSpPr>
@@ -9499,7 +9460,7 @@
       </p:sp>
       <p:sp>
         <p:nvSpPr>
-          <p:cNvPr id="100177" name="Fixed-6"/>
+          <p:cNvPr id="100176" name="Fixed-6"/>
           <p:cNvSpPr/>
           <p:nvPr/>
         </p:nvSpPr>
@@ -9538,7 +9499,7 @@
       </p:sp>
       <p:sp>
         <p:nvSpPr>
-          <p:cNvPr id="100178" name="Fixed-7"/>
+          <p:cNvPr id="100177" name="Fixed-7"/>
           <p:cNvSpPr/>
           <p:nvPr/>
         </p:nvSpPr>
@@ -9577,7 +9538,7 @@
       </p:sp>
       <p:sp>
         <p:nvSpPr>
-          <p:cNvPr id="100179" name="Element-8"/>
+          <p:cNvPr id="100178" name="Element-8"/>
           <p:cNvSpPr/>
           <p:nvPr/>
         </p:nvSpPr>
@@ -9615,7 +9576,7 @@
       </p:sp>
       <p:sp>
         <p:nvSpPr>
-          <p:cNvPr id="100180" name="Fixed-9"/>
+          <p:cNvPr id="100179" name="Fixed-9"/>
           <p:cNvSpPr/>
           <p:nvPr/>
         </p:nvSpPr>
@@ -9654,7 +9615,7 @@
       </p:sp>
       <p:sp>
         <p:nvSpPr>
-          <p:cNvPr id="100181" name="Title"/>
+          <p:cNvPr id="100180" name="Title"/>
           <p:cNvSpPr/>
           <p:nvPr/>
         </p:nvSpPr>
@@ -9693,7 +9654,7 @@
       </p:sp>
       <p:sp>
         <p:nvSpPr>
-          <p:cNvPr id="100182" name="Element-11"/>
+          <p:cNvPr id="100181" name="Element-11"/>
           <p:cNvSpPr/>
           <p:nvPr/>
         </p:nvSpPr>
@@ -9731,7 +9692,7 @@
       </p:sp>
       <p:sp>
         <p:nvSpPr>
-          <p:cNvPr id="100183" name="Fixed-12"/>
+          <p:cNvPr id="100182" name="Fixed-12"/>
           <p:cNvSpPr/>
           <p:nvPr/>
         </p:nvSpPr>
@@ -9770,7 +9731,7 @@
       </p:sp>
       <p:sp>
         <p:nvSpPr>
-          <p:cNvPr id="100184" name="Fixed-13"/>
+          <p:cNvPr id="100183" name="Fixed-13"/>
           <p:cNvSpPr/>
           <p:nvPr/>
         </p:nvSpPr>
@@ -9809,7 +9770,7 @@
       </p:sp>
       <p:sp>
         <p:nvSpPr>
-          <p:cNvPr id="100185" name="Fixed-14"/>
+          <p:cNvPr id="100184" name="Fixed-14"/>
           <p:cNvSpPr/>
           <p:nvPr/>
         </p:nvSpPr>
@@ -9848,7 +9809,7 @@
       </p:sp>
       <p:sp>
         <p:nvSpPr>
-          <p:cNvPr id="100186" name="Fixed-15"/>
+          <p:cNvPr id="100185" name="Fixed-15"/>
           <p:cNvSpPr/>
           <p:nvPr/>
         </p:nvSpPr>
@@ -9887,7 +9848,7 @@
       </p:sp>
       <p:sp>
         <p:nvSpPr>
-          <p:cNvPr id="100187" name="Element-16"/>
+          <p:cNvPr id="100186" name="Element-16"/>
           <p:cNvSpPr/>
           <p:nvPr/>
         </p:nvSpPr>
@@ -9925,7 +9886,7 @@
       </p:sp>
       <p:sp>
         <p:nvSpPr>
-          <p:cNvPr id="100188" name="Fixed-17"/>
+          <p:cNvPr id="100187" name="Fixed-17"/>
           <p:cNvSpPr/>
           <p:nvPr/>
         </p:nvSpPr>
@@ -9964,7 +9925,7 @@
       </p:sp>
       <p:sp>
         <p:nvSpPr>
-          <p:cNvPr id="100189" name="Fixed-18"/>
+          <p:cNvPr id="100188" name="Fixed-18"/>
           <p:cNvSpPr/>
           <p:nvPr/>
         </p:nvSpPr>
@@ -10003,7 +9964,7 @@
       </p:sp>
       <p:sp>
         <p:nvSpPr>
-          <p:cNvPr id="100190" name="Fixed-19"/>
+          <p:cNvPr id="100189" name="Fixed-19"/>
           <p:cNvSpPr/>
           <p:nvPr/>
         </p:nvSpPr>
@@ -10042,7 +10003,7 @@
       </p:sp>
       <p:sp>
         <p:nvSpPr>
-          <p:cNvPr id="100191" name="Element-20"/>
+          <p:cNvPr id="100190" name="Element-20"/>
           <p:cNvSpPr/>
           <p:nvPr/>
         </p:nvSpPr>
@@ -10080,7 +10041,7 @@
       </p:sp>
       <p:sp>
         <p:nvSpPr>
-          <p:cNvPr id="100192" name="Fixed-21"/>
+          <p:cNvPr id="100191" name="Fixed-21"/>
           <p:cNvSpPr/>
           <p:nvPr/>
         </p:nvSpPr>
@@ -10119,7 +10080,7 @@
       </p:sp>
       <p:sp>
         <p:nvSpPr>
-          <p:cNvPr id="100193" name="Fixed-22"/>
+          <p:cNvPr id="100192" name="Fixed-22"/>
           <p:cNvSpPr/>
           <p:nvPr/>
         </p:nvSpPr>
@@ -10158,7 +10119,7 @@
       </p:sp>
       <p:sp>
         <p:nvSpPr>
-          <p:cNvPr id="100194" name="Fixed-23"/>
+          <p:cNvPr id="100193" name="Fixed-23"/>
           <p:cNvSpPr/>
           <p:nvPr/>
         </p:nvSpPr>
@@ -10197,7 +10158,7 @@
       </p:sp>
       <p:sp>
         <p:nvSpPr>
-          <p:cNvPr id="100195" name="Element-24"/>
+          <p:cNvPr id="100194" name="Element-24"/>
           <p:cNvSpPr/>
           <p:nvPr/>
         </p:nvSpPr>
@@ -10235,7 +10196,7 @@
       </p:sp>
       <p:sp>
         <p:nvSpPr>
-          <p:cNvPr id="100196" name="Fixed-25"/>
+          <p:cNvPr id="100195" name="Fixed-25"/>
           <p:cNvSpPr/>
           <p:nvPr/>
         </p:nvSpPr>
@@ -10274,7 +10235,7 @@
       </p:sp>
       <p:sp>
         <p:nvSpPr>
-          <p:cNvPr id="100197" name="Fixed-26"/>
+          <p:cNvPr id="100196" name="Fixed-26"/>
           <p:cNvSpPr/>
           <p:nvPr/>
         </p:nvSpPr>
@@ -10313,7 +10274,7 @@
       </p:sp>
       <p:sp>
         <p:nvSpPr>
-          <p:cNvPr id="100198" name="Fixed-27"/>
+          <p:cNvPr id="100197" name="Fixed-27"/>
           <p:cNvSpPr/>
           <p:nvPr/>
         </p:nvSpPr>
@@ -10352,7 +10313,7 @@
       </p:sp>
       <p:sp>
         <p:nvSpPr>
-          <p:cNvPr id="100199" name="Element-28"/>
+          <p:cNvPr id="100198" name="Element-28"/>
           <p:cNvSpPr/>
           <p:nvPr/>
         </p:nvSpPr>
@@ -10390,7 +10351,7 @@
       </p:sp>
       <p:sp>
         <p:nvSpPr>
-          <p:cNvPr id="100200" name="Fixed-29"/>
+          <p:cNvPr id="100199" name="Fixed-29"/>
           <p:cNvSpPr/>
           <p:nvPr/>
         </p:nvSpPr>
@@ -10429,7 +10390,7 @@
       </p:sp>
       <p:sp>
         <p:nvSpPr>
-          <p:cNvPr id="100201" name="Fixed-30"/>
+          <p:cNvPr id="100200" name="Fixed-30"/>
           <p:cNvSpPr/>
           <p:nvPr/>
         </p:nvSpPr>
@@ -10468,7 +10429,7 @@
       </p:sp>
       <p:sp>
         <p:nvSpPr>
-          <p:cNvPr id="100202" name="Fixed-31"/>
+          <p:cNvPr id="100201" name="Fixed-31"/>
           <p:cNvSpPr/>
           <p:nvPr/>
         </p:nvSpPr>
@@ -10507,7 +10468,7 @@
       </p:sp>
       <p:sp>
         <p:nvSpPr>
-          <p:cNvPr id="100203" name="Element-32"/>
+          <p:cNvPr id="100202" name="Element-32"/>
           <p:cNvSpPr/>
           <p:nvPr/>
         </p:nvSpPr>
@@ -10545,7 +10506,7 @@
       </p:sp>
       <p:sp>
         <p:nvSpPr>
-          <p:cNvPr id="100204" name="Fixed-33"/>
+          <p:cNvPr id="100203" name="Fixed-33"/>
           <p:cNvSpPr/>
           <p:nvPr/>
         </p:nvSpPr>
@@ -10584,7 +10545,7 @@
       </p:sp>
       <p:sp>
         <p:nvSpPr>
-          <p:cNvPr id="100205" name="Fixed-34"/>
+          <p:cNvPr id="100204" name="Fixed-34"/>
           <p:cNvSpPr/>
           <p:nvPr/>
         </p:nvSpPr>
@@ -10623,7 +10584,7 @@
       </p:sp>
       <p:sp>
         <p:nvSpPr>
-          <p:cNvPr id="100206" name="Fixed-35"/>
+          <p:cNvPr id="100205" name="Fixed-35"/>
           <p:cNvSpPr/>
           <p:nvPr/>
         </p:nvSpPr>
@@ -10662,7 +10623,7 @@
       </p:sp>
       <p:sp>
         <p:nvSpPr>
-          <p:cNvPr id="100207" name="Element-36"/>
+          <p:cNvPr id="100206" name="Element-36"/>
           <p:cNvSpPr/>
           <p:nvPr/>
         </p:nvSpPr>
@@ -10700,7 +10661,7 @@
       </p:sp>
       <p:sp>
         <p:nvSpPr>
-          <p:cNvPr id="100208" name="Element-37"/>
+          <p:cNvPr id="100207" name="Element-37"/>
           <p:cNvSpPr/>
           <p:nvPr/>
         </p:nvSpPr>
@@ -10738,7 +10699,7 @@
       </p:sp>
       <p:sp>
         <p:nvSpPr>
-          <p:cNvPr id="100209" name="Caption-8"/>
+          <p:cNvPr id="100208" name="Caption-8"/>
           <p:cNvSpPr/>
           <p:nvPr/>
         </p:nvSpPr>
@@ -10777,7 +10738,7 @@
       </p:sp>
       <p:sp>
         <p:nvSpPr>
-          <p:cNvPr id="100210" name="Fixed-39"/>
+          <p:cNvPr id="100209" name="Fixed-39"/>
           <p:cNvSpPr/>
           <p:nvPr/>
         </p:nvSpPr>
@@ -10816,7 +10777,7 @@
       </p:sp>
       <p:sp>
         <p:nvSpPr>
-          <p:cNvPr id="100211" name="Fixed-40"/>
+          <p:cNvPr id="100210" name="Fixed-40"/>
           <p:cNvSpPr/>
           <p:nvPr/>
         </p:nvSpPr>
@@ -10877,14 +10838,14 @@
       <p:grpSpPr/>
       <p:pic>
         <p:nvPicPr>
-          <p:cNvPr id="100212" name="Picture 1" descr="SMart ILIA — UMONS"/>
+          <p:cNvPr id="100211" name="Picture 1" descr="SMart ILIA — UMONS"/>
           <p:cNvPicPr>
             <a:picLocks xmlns:a="http://schemas.openxmlformats.org/drawingml/2006/main" noChangeAspect="1"/>
           </p:cNvPicPr>
           <p:nvPr/>
         </p:nvPicPr>
         <p:blipFill>
-          <a:blip xmlns:r="http://schemas.openxmlformats.org/officeDocument/2006/relationships" xmlns:a="http://schemas.openxmlformats.org/drawingml/2006/main" r:embed="Rddc576ff0b634863"/>
+          <a:blip xmlns:r="http://schemas.openxmlformats.org/officeDocument/2006/relationships" xmlns:a="http://schemas.openxmlformats.org/drawingml/2006/main" r:embed="Rc43f346d199e4aa3"/>
           <a:stretch xmlns:a="http://schemas.openxmlformats.org/drawingml/2006/main">
             <a:fillRect/>
           </a:stretch>
@@ -10901,7 +10862,7 @@
       </p:pic>
       <p:sp>
         <p:nvSpPr>
-          <p:cNvPr id="100213" name="Fixed-4"/>
+          <p:cNvPr id="100212" name="Fixed-4"/>
           <p:cNvSpPr/>
           <p:nvPr/>
         </p:nvSpPr>
@@ -10940,7 +10901,7 @@
       </p:sp>
       <p:sp>
         <p:nvSpPr>
-          <p:cNvPr id="100214" name="Fixed-5"/>
+          <p:cNvPr id="100213" name="Fixed-5"/>
           <p:cNvSpPr/>
           <p:nvPr/>
         </p:nvSpPr>
@@ -10979,7 +10940,7 @@
       </p:sp>
       <p:sp>
         <p:nvSpPr>
-          <p:cNvPr id="100215" name="Fixed-6"/>
+          <p:cNvPr id="100214" name="Fixed-6"/>
           <p:cNvSpPr/>
           <p:nvPr/>
         </p:nvSpPr>
@@ -11018,7 +10979,7 @@
       </p:sp>
       <p:sp>
         <p:nvSpPr>
-          <p:cNvPr id="100216" name="Fixed-7"/>
+          <p:cNvPr id="100215" name="Fixed-7"/>
           <p:cNvSpPr/>
           <p:nvPr/>
         </p:nvSpPr>
@@ -11057,7 +11018,7 @@
       </p:sp>
       <p:sp>
         <p:nvSpPr>
-          <p:cNvPr id="100217" name="Fixed-8"/>
+          <p:cNvPr id="100216" name="Fixed-8"/>
           <p:cNvSpPr/>
           <p:nvPr/>
         </p:nvSpPr>
@@ -11096,7 +11057,7 @@
       </p:sp>
       <p:sp>
         <p:nvSpPr>
-          <p:cNvPr id="100218" name="Element-9"/>
+          <p:cNvPr id="100217" name="Element-9"/>
           <p:cNvSpPr/>
           <p:nvPr/>
         </p:nvSpPr>
@@ -11134,7 +11095,7 @@
       </p:sp>
       <p:sp>
         <p:nvSpPr>
-          <p:cNvPr id="100219" name="Title"/>
+          <p:cNvPr id="100218" name="Title"/>
           <p:cNvSpPr/>
           <p:nvPr/>
         </p:nvSpPr>
@@ -11173,7 +11134,7 @@
       </p:sp>
       <p:sp>
         <p:nvSpPr>
-          <p:cNvPr id="100220" name="Element-11"/>
+          <p:cNvPr id="100219" name="Element-11"/>
           <p:cNvSpPr/>
           <p:nvPr/>
         </p:nvSpPr>
@@ -11211,7 +11172,7 @@
       </p:sp>
       <p:sp>
         <p:nvSpPr>
-          <p:cNvPr id="100221" name="Fixed-12"/>
+          <p:cNvPr id="100220" name="Fixed-12"/>
           <p:cNvSpPr/>
           <p:nvPr/>
         </p:nvSpPr>
@@ -11250,7 +11211,7 @@
       </p:sp>
       <p:sp>
         <p:nvSpPr>
-          <p:cNvPr id="100222" name="Fixed-13"/>
+          <p:cNvPr id="100221" name="Fixed-13"/>
           <p:cNvSpPr/>
           <p:nvPr/>
         </p:nvSpPr>
@@ -11289,7 +11250,7 @@
       </p:sp>
       <p:sp>
         <p:nvSpPr>
-          <p:cNvPr id="100223" name="Fixed-14"/>
+          <p:cNvPr id="100222" name="Fixed-14"/>
           <p:cNvSpPr/>
           <p:nvPr/>
         </p:nvSpPr>
@@ -11328,7 +11289,7 @@
       </p:sp>
       <p:sp>
         <p:nvSpPr>
-          <p:cNvPr id="100224" name="Fixed-15"/>
+          <p:cNvPr id="100223" name="Fixed-15"/>
           <p:cNvSpPr/>
           <p:nvPr/>
         </p:nvSpPr>
@@ -11367,7 +11328,7 @@
       </p:sp>
       <p:sp>
         <p:nvSpPr>
-          <p:cNvPr id="100225" name="Fixed-16"/>
+          <p:cNvPr id="100224" name="Fixed-16"/>
           <p:cNvSpPr/>
           <p:nvPr/>
         </p:nvSpPr>
@@ -11406,7 +11367,7 @@
       </p:sp>
       <p:sp>
         <p:nvSpPr>
-          <p:cNvPr id="100226" name="Fixed-17"/>
+          <p:cNvPr id="100225" name="Fixed-17"/>
           <p:cNvSpPr/>
           <p:nvPr/>
         </p:nvSpPr>
@@ -11445,7 +11406,7 @@
       </p:sp>
       <p:sp>
         <p:nvSpPr>
-          <p:cNvPr id="100227" name="Fixed-18"/>
+          <p:cNvPr id="100226" name="Fixed-18"/>
           <p:cNvSpPr/>
           <p:nvPr/>
         </p:nvSpPr>
@@ -11484,7 +11445,7 @@
       </p:sp>
       <p:sp>
         <p:nvSpPr>
-          <p:cNvPr id="100228" name="Fixed-19"/>
+          <p:cNvPr id="100227" name="Fixed-19"/>
           <p:cNvSpPr/>
           <p:nvPr/>
         </p:nvSpPr>
@@ -11523,7 +11484,7 @@
       </p:sp>
       <p:sp>
         <p:nvSpPr>
-          <p:cNvPr id="100229" name="Element-20"/>
+          <p:cNvPr id="100228" name="Element-20"/>
           <p:cNvSpPr/>
           <p:nvPr/>
         </p:nvSpPr>
@@ -11563,7 +11524,7 @@
       </p:sp>
       <p:sp>
         <p:nvSpPr>
-          <p:cNvPr id="100230" name="Element-21"/>
+          <p:cNvPr id="100229" name="Element-21"/>
           <p:cNvSpPr/>
           <p:nvPr/>
         </p:nvSpPr>
@@ -11601,7 +11562,7 @@
       </p:sp>
       <p:sp>
         <p:nvSpPr>
-          <p:cNvPr id="100231" name="Fixed-22"/>
+          <p:cNvPr id="100230" name="Fixed-22"/>
           <p:cNvSpPr/>
           <p:nvPr/>
         </p:nvSpPr>
@@ -11640,7 +11601,7 @@
       </p:sp>
       <p:sp>
         <p:nvSpPr>
-          <p:cNvPr id="100232" name="Element-23"/>
+          <p:cNvPr id="100231" name="Element-23"/>
           <p:cNvSpPr/>
           <p:nvPr/>
         </p:nvSpPr>
@@ -11678,7 +11639,7 @@
       </p:sp>
       <p:sp>
         <p:nvSpPr>
-          <p:cNvPr id="100233" name="Fixed-24"/>
+          <p:cNvPr id="100232" name="Fixed-24"/>
           <p:cNvSpPr/>
           <p:nvPr/>
         </p:nvSpPr>
@@ -11717,7 +11678,7 @@
       </p:sp>
       <p:sp>
         <p:nvSpPr>
-          <p:cNvPr id="100234" name="Element-25"/>
+          <p:cNvPr id="100233" name="Element-25"/>
           <p:cNvSpPr/>
           <p:nvPr/>
         </p:nvSpPr>
@@ -11755,7 +11716,7 @@
       </p:sp>
       <p:sp>
         <p:nvSpPr>
-          <p:cNvPr id="100235" name="Fixed-26"/>
+          <p:cNvPr id="100234" name="Fixed-26"/>
           <p:cNvSpPr/>
           <p:nvPr/>
         </p:nvSpPr>
@@ -11794,7 +11755,7 @@
       </p:sp>
       <p:sp>
         <p:nvSpPr>
-          <p:cNvPr id="100236" name="Element-27"/>
+          <p:cNvPr id="100235" name="Element-27"/>
           <p:cNvSpPr/>
           <p:nvPr/>
         </p:nvSpPr>
@@ -11832,7 +11793,7 @@
       </p:sp>
       <p:sp>
         <p:nvSpPr>
-          <p:cNvPr id="100237" name="Caption-9"/>
+          <p:cNvPr id="100236" name="Caption-9"/>
           <p:cNvSpPr/>
           <p:nvPr/>
         </p:nvSpPr>
@@ -11871,7 +11832,7 @@
       </p:sp>
       <p:sp>
         <p:nvSpPr>
-          <p:cNvPr id="100238" name="Fixed-29"/>
+          <p:cNvPr id="100237" name="Fixed-29"/>
           <p:cNvSpPr/>
           <p:nvPr/>
         </p:nvSpPr>
@@ -11903,14 +11864,14 @@
                 <a:latin typeface="Arial"/>
                 <a:ea typeface="Arial"/>
               </a:rPr>
-              <a:t>Support line: AsiaCCS 2027 submission, 11 December 2026 (AoE).</a:t>
-            </a:r>
-          </a:p>
-        </p:txBody>
-      </p:sp>
-      <p:sp>
-        <p:nvSpPr>
-          <p:cNvPr id="100239" name="Fixed-30"/>
+              <a:t>AsiaCCS 2027 submission deadline: 11 December 2026, anywhere on Earth.</a:t>
+            </a:r>
+          </a:p>
+        </p:txBody>
+      </p:sp>
+      <p:sp>
+        <p:nvSpPr>
+          <p:cNvPr id="100238" name="Fixed-30"/>
           <p:cNvSpPr/>
           <p:nvPr/>
         </p:nvSpPr>
@@ -11949,7 +11910,7 @@
       </p:sp>
       <p:sp>
         <p:nvSpPr>
-          <p:cNvPr id="100240" name="Fixed-31"/>
+          <p:cNvPr id="100239" name="Fixed-31"/>
           <p:cNvSpPr/>
           <p:nvPr/>
         </p:nvSpPr>

</xml_diff>